<commit_message>
Polish: softer colors, supplementary data, per-capita analysis
</commit_message>
<xml_diff>
--- a/outputs/final/presentation.pptx
+++ b/outputs/final/presentation.pptx
@@ -4,9 +4,6 @@
   <p:sldMasterIdLst>
     <p:sldMasterId id="2147483648" r:id="rId1"/>
   </p:sldMasterIdLst>
-  <p:notesMasterIdLst>
-    <p:notesMasterId r:id="rId19"/>
-  </p:notesMasterIdLst>
   <p:sldIdLst>
     <p:sldId id="256" r:id="rId2"/>
     <p:sldId id="257" r:id="rId3"/>
@@ -26,7 +23,10 @@
     <p:sldId id="271" r:id="rId17"/>
     <p:sldId id="272" r:id="rId18"/>
   </p:sldIdLst>
-  <p:sldSz cx="9144000" cy="5143500" type="screen16x9"/>
+  <p:notesMasterIdLst>
+    <p:notesMasterId r:id="rId19"/>
+  </p:notesMasterIdLst>
+  <p:sldSz cx="9144000" cy="5143500"/>
   <p:notesSz cx="5143500" cy="9144000"/>
   <p:defaultTextStyle>
     <a:lvl1pPr marL="0" algn="l" defTabSz="914400" rtl="0" eaLnBrk="1" latinLnBrk="0" hangingPunct="1">
@@ -120,11 +120,6 @@
       </a:defRPr>
     </a:lvl9pPr>
   </p:defaultTextStyle>
-  <p:extLst>
-    <p:ext uri="{EFAFB233-063F-42B5-8137-9DF3F51BA10A}">
-      <p15:sldGuideLst xmlns:p15="http://schemas.microsoft.com/office/powerpoint/2012/main"/>
-    </p:ext>
-  </p:extLst>
 </p:presentation>
 </file>
 
@@ -150,10 +145,234 @@
           <a:chExt cx="0" cy="0"/>
         </a:xfrm>
       </p:grpSpPr>
+      <p:sp>
+        <p:nvSpPr>
+          <p:cNvPr id="2" name="Header Placeholder 1"/>
+          <p:cNvSpPr>
+            <a:spLocks noGrp="1"/>
+          </p:cNvSpPr>
+          <p:nvPr>
+            <p:ph type="hdr" sz="quarter"/>
+          </p:nvPr>
+        </p:nvSpPr>
+        <p:spPr>
+          <a:xfrm>
+            <a:off x="0" y="0"/>
+            <a:ext cx="2971800" cy="458788"/>
+          </a:xfrm>
+          <a:prstGeom prst="rect">
+            <a:avLst/>
+          </a:prstGeom>
+        </p:spPr>
+        <p:txBody>
+          <a:bodyPr vert="horz" lIns="91440" tIns="45720" rIns="91440" bIns="45720" rtlCol="0"/>
+          <a:lstStyle>
+            <a:lvl1pPr algn="l">
+              <a:defRPr sz="1200"/>
+            </a:lvl1pPr>
+          </a:lstStyle>
+          <a:p>
+            <a:endParaRPr lang="en-US"/>
+          </a:p>
+        </p:txBody>
+      </p:sp>
+      <p:sp>
+        <p:nvSpPr>
+          <p:cNvPr id="3" name="Date Placeholder 2"/>
+          <p:cNvSpPr>
+            <a:spLocks noGrp="1"/>
+          </p:cNvSpPr>
+          <p:nvPr>
+            <p:ph type="dt" idx="1"/>
+          </p:nvPr>
+        </p:nvSpPr>
+        <p:spPr>
+          <a:xfrm>
+            <a:off x="3884613" y="0"/>
+            <a:ext cx="2971800" cy="458788"/>
+          </a:xfrm>
+          <a:prstGeom prst="rect">
+            <a:avLst/>
+          </a:prstGeom>
+        </p:spPr>
+        <p:txBody>
+          <a:bodyPr vert="horz" lIns="91440" tIns="45720" rIns="91440" bIns="45720" rtlCol="0"/>
+          <a:lstStyle>
+            <a:lvl1pPr algn="r">
+              <a:defRPr sz="1200"/>
+            </a:lvl1pPr>
+          </a:lstStyle>
+          <a:p>
+            <a:fld id="{5282F153-3F37-0F45-9E97-73ACFA13230C}" type="datetimeFigureOut">
+              <a:rPr lang="en-US"/>
+              <a:t>7/23/19</a:t>
+            </a:fld>
+            <a:endParaRPr lang="en-US"/>
+          </a:p>
+        </p:txBody>
+      </p:sp>
+      <p:sp>
+        <p:nvSpPr>
+          <p:cNvPr id="4" name="Slide Image Placeholder 3"/>
+          <p:cNvSpPr>
+            <a:spLocks noGrp="1" noRot="1" noChangeAspect="1"/>
+          </p:cNvSpPr>
+          <p:nvPr>
+            <p:ph type="sldImg" idx="2"/>
+          </p:nvPr>
+        </p:nvSpPr>
+        <p:spPr>
+          <a:xfrm>
+            <a:off x="685800" y="1143000"/>
+            <a:ext cx="5486400" cy="3086100"/>
+          </a:xfrm>
+          <a:prstGeom prst="rect">
+            <a:avLst/>
+          </a:prstGeom>
+          <a:noFill/>
+          <a:ln w="12700">
+            <a:solidFill>
+              <a:prstClr val="black"/>
+            </a:solidFill>
+          </a:ln>
+        </p:spPr>
+        <p:txBody>
+          <a:bodyPr vert="horz" lIns="91440" tIns="45720" rIns="91440" bIns="45720" rtlCol="0" anchor="ctr"/>
+          <a:lstStyle/>
+          <a:p>
+            <a:endParaRPr lang="en-US"/>
+          </a:p>
+        </p:txBody>
+      </p:sp>
+      <p:sp>
+        <p:nvSpPr>
+          <p:cNvPr id="5" name="Notes Placeholder 4"/>
+          <p:cNvSpPr>
+            <a:spLocks noGrp="1"/>
+          </p:cNvSpPr>
+          <p:nvPr>
+            <p:ph type="body" sz="quarter" idx="3"/>
+          </p:nvPr>
+        </p:nvSpPr>
+        <p:spPr>
+          <a:xfrm>
+            <a:off x="685800" y="4400550"/>
+            <a:ext cx="5486400" cy="3600450"/>
+          </a:xfrm>
+          <a:prstGeom prst="rect">
+            <a:avLst/>
+          </a:prstGeom>
+        </p:spPr>
+        <p:txBody>
+          <a:bodyPr vert="horz" lIns="91440" tIns="45720" rIns="91440" bIns="45720" rtlCol="0"/>
+          <a:lstStyle/>
+          <a:p>
+            <a:pPr lvl="0"/>
+            <a:r>
+              <a:rPr lang="en-US"/>
+              <a:t>Click to edit Master text styles</a:t>
+            </a:r>
+          </a:p>
+          <a:p>
+            <a:pPr lvl="1"/>
+            <a:r>
+              <a:rPr lang="en-US"/>
+              <a:t>Second level</a:t>
+            </a:r>
+          </a:p>
+          <a:p>
+            <a:pPr lvl="2"/>
+            <a:r>
+              <a:rPr lang="en-US"/>
+              <a:t>Third level</a:t>
+            </a:r>
+          </a:p>
+          <a:p>
+            <a:pPr lvl="3"/>
+            <a:r>
+              <a:rPr lang="en-US"/>
+              <a:t>Fourth level</a:t>
+            </a:r>
+          </a:p>
+          <a:p>
+            <a:pPr lvl="4"/>
+            <a:r>
+              <a:rPr lang="en-US"/>
+              <a:t>Fifth level</a:t>
+            </a:r>
+          </a:p>
+        </p:txBody>
+      </p:sp>
+      <p:sp>
+        <p:nvSpPr>
+          <p:cNvPr id="6" name="Footer Placeholder 5"/>
+          <p:cNvSpPr>
+            <a:spLocks noGrp="1"/>
+          </p:cNvSpPr>
+          <p:nvPr>
+            <p:ph type="ftr" sz="quarter" idx="4"/>
+          </p:nvPr>
+        </p:nvSpPr>
+        <p:spPr>
+          <a:xfrm>
+            <a:off x="0" y="8685213"/>
+            <a:ext cx="2971800" cy="458787"/>
+          </a:xfrm>
+          <a:prstGeom prst="rect">
+            <a:avLst/>
+          </a:prstGeom>
+        </p:spPr>
+        <p:txBody>
+          <a:bodyPr vert="horz" lIns="91440" tIns="45720" rIns="91440" bIns="45720" rtlCol="0" anchor="b"/>
+          <a:lstStyle>
+            <a:lvl1pPr algn="l">
+              <a:defRPr sz="1200"/>
+            </a:lvl1pPr>
+          </a:lstStyle>
+          <a:p>
+            <a:endParaRPr lang="en-US"/>
+          </a:p>
+        </p:txBody>
+      </p:sp>
+      <p:sp>
+        <p:nvSpPr>
+          <p:cNvPr id="7" name="Slide Number Placeholder 6"/>
+          <p:cNvSpPr>
+            <a:spLocks noGrp="1"/>
+          </p:cNvSpPr>
+          <p:nvPr>
+            <p:ph type="sldNum" sz="quarter" idx="5"/>
+          </p:nvPr>
+        </p:nvSpPr>
+        <p:spPr>
+          <a:xfrm>
+            <a:off x="3884613" y="8685213"/>
+            <a:ext cx="2971800" cy="458787"/>
+          </a:xfrm>
+          <a:prstGeom prst="rect">
+            <a:avLst/>
+          </a:prstGeom>
+        </p:spPr>
+        <p:txBody>
+          <a:bodyPr vert="horz" lIns="91440" tIns="45720" rIns="91440" bIns="45720" rtlCol="0" anchor="b"/>
+          <a:lstStyle>
+            <a:lvl1pPr algn="r">
+              <a:defRPr sz="1200"/>
+            </a:lvl1pPr>
+          </a:lstStyle>
+          <a:p>
+            <a:fld id="{CE5E9CC1-C706-0F49-92D6-E571CC5EEA8F}" type="slidenum">
+              <a:rPr lang="en-US"/>
+              <a:t>‹#›</a:t>
+            </a:fld>
+            <a:endParaRPr lang="en-US"/>
+          </a:p>
+        </p:txBody>
+      </p:sp>
     </p:spTree>
     <p:extLst>
       <p:ext uri="{BB962C8B-B14F-4D97-AF65-F5344CB8AC3E}">
-        <p14:creationId xmlns:p14="http://schemas.microsoft.com/office/powerpoint/2010/main" val="3742893786"/>
+        <p14:creationId xmlns:p14="http://schemas.microsoft.com/office/powerpoint/2010/main" val="1024086991"/>
       </p:ext>
     </p:extLst>
   </p:cSld>
@@ -297,6 +516,10 @@
           <a:bodyPr/>
           <a:lstStyle/>
           <a:p>
+            <a:r>
+              <a:rPr lang="en-US" dirty="0"/>
+              <a:t/>
+            </a:r>
             <a:endParaRPr lang="en-US" dirty="0"/>
           </a:p>
         </p:txBody>
@@ -381,6 +604,10 @@
           <a:bodyPr/>
           <a:lstStyle/>
           <a:p>
+            <a:r>
+              <a:rPr lang="en-US" dirty="0"/>
+              <a:t/>
+            </a:r>
             <a:endParaRPr lang="en-US" dirty="0"/>
           </a:p>
         </p:txBody>
@@ -465,6 +692,10 @@
           <a:bodyPr/>
           <a:lstStyle/>
           <a:p>
+            <a:r>
+              <a:rPr lang="en-US" dirty="0"/>
+              <a:t/>
+            </a:r>
             <a:endParaRPr lang="en-US" dirty="0"/>
           </a:p>
         </p:txBody>
@@ -549,6 +780,10 @@
           <a:bodyPr/>
           <a:lstStyle/>
           <a:p>
+            <a:r>
+              <a:rPr lang="en-US" dirty="0"/>
+              <a:t/>
+            </a:r>
             <a:endParaRPr lang="en-US" dirty="0"/>
           </a:p>
         </p:txBody>
@@ -633,6 +868,10 @@
           <a:bodyPr/>
           <a:lstStyle/>
           <a:p>
+            <a:r>
+              <a:rPr lang="en-US" dirty="0"/>
+              <a:t/>
+            </a:r>
             <a:endParaRPr lang="en-US" dirty="0"/>
           </a:p>
         </p:txBody>
@@ -717,6 +956,10 @@
           <a:bodyPr/>
           <a:lstStyle/>
           <a:p>
+            <a:r>
+              <a:rPr lang="en-US" dirty="0"/>
+              <a:t/>
+            </a:r>
             <a:endParaRPr lang="en-US" dirty="0"/>
           </a:p>
         </p:txBody>
@@ -801,6 +1044,10 @@
           <a:bodyPr/>
           <a:lstStyle/>
           <a:p>
+            <a:r>
+              <a:rPr lang="en-US" dirty="0"/>
+              <a:t/>
+            </a:r>
             <a:endParaRPr lang="en-US" dirty="0"/>
           </a:p>
         </p:txBody>
@@ -885,6 +1132,10 @@
           <a:bodyPr/>
           <a:lstStyle/>
           <a:p>
+            <a:r>
+              <a:rPr lang="en-US" dirty="0"/>
+              <a:t/>
+            </a:r>
             <a:endParaRPr lang="en-US" dirty="0"/>
           </a:p>
         </p:txBody>
@@ -969,6 +1220,10 @@
           <a:bodyPr/>
           <a:lstStyle/>
           <a:p>
+            <a:r>
+              <a:rPr lang="en-US" dirty="0"/>
+              <a:t/>
+            </a:r>
             <a:endParaRPr lang="en-US" dirty="0"/>
           </a:p>
         </p:txBody>
@@ -1053,6 +1308,10 @@
           <a:bodyPr/>
           <a:lstStyle/>
           <a:p>
+            <a:r>
+              <a:rPr lang="en-US" dirty="0"/>
+              <a:t/>
+            </a:r>
             <a:endParaRPr lang="en-US" dirty="0"/>
           </a:p>
         </p:txBody>
@@ -1137,6 +1396,10 @@
           <a:bodyPr/>
           <a:lstStyle/>
           <a:p>
+            <a:r>
+              <a:rPr lang="en-US" dirty="0"/>
+              <a:t/>
+            </a:r>
             <a:endParaRPr lang="en-US" dirty="0"/>
           </a:p>
         </p:txBody>
@@ -1221,6 +1484,10 @@
           <a:bodyPr/>
           <a:lstStyle/>
           <a:p>
+            <a:r>
+              <a:rPr lang="en-US" dirty="0"/>
+              <a:t/>
+            </a:r>
             <a:endParaRPr lang="en-US" dirty="0"/>
           </a:p>
         </p:txBody>
@@ -1305,6 +1572,10 @@
           <a:bodyPr/>
           <a:lstStyle/>
           <a:p>
+            <a:r>
+              <a:rPr lang="en-US" dirty="0"/>
+              <a:t/>
+            </a:r>
             <a:endParaRPr lang="en-US" dirty="0"/>
           </a:p>
         </p:txBody>
@@ -1389,6 +1660,10 @@
           <a:bodyPr/>
           <a:lstStyle/>
           <a:p>
+            <a:r>
+              <a:rPr lang="en-US" dirty="0"/>
+              <a:t/>
+            </a:r>
             <a:endParaRPr lang="en-US" dirty="0"/>
           </a:p>
         </p:txBody>
@@ -1473,6 +1748,10 @@
           <a:bodyPr/>
           <a:lstStyle/>
           <a:p>
+            <a:r>
+              <a:rPr lang="en-US" dirty="0"/>
+              <a:t/>
+            </a:r>
             <a:endParaRPr lang="en-US" dirty="0"/>
           </a:p>
         </p:txBody>
@@ -1557,6 +1836,10 @@
           <a:bodyPr/>
           <a:lstStyle/>
           <a:p>
+            <a:r>
+              <a:rPr lang="en-US" dirty="0"/>
+              <a:t/>
+            </a:r>
             <a:endParaRPr lang="en-US" dirty="0"/>
           </a:p>
         </p:txBody>
@@ -1641,6 +1924,10 @@
           <a:bodyPr/>
           <a:lstStyle/>
           <a:p>
+            <a:r>
+              <a:rPr lang="en-US" dirty="0"/>
+              <a:t/>
+            </a:r>
             <a:endParaRPr lang="en-US" dirty="0"/>
           </a:p>
         </p:txBody>
@@ -1714,11 +2001,6 @@
 <file path=ppt/slideMasters/slideMaster1.xml><?xml version="1.0" encoding="utf-8"?>
 <p:sldMaster xmlns:a="http://schemas.openxmlformats.org/drawingml/2006/main" xmlns:r="http://schemas.openxmlformats.org/officeDocument/2006/relationships" xmlns:p="http://schemas.openxmlformats.org/presentationml/2006/main">
   <p:cSld>
-    <p:bg>
-      <p:bgRef idx="1001">
-        <a:schemeClr val="bg1"/>
-      </p:bgRef>
-    </p:bg>
     <p:spTree>
       <p:nvGrpSpPr>
         <p:cNvPr id="1" name=""/>
@@ -1999,9 +2281,8 @@
     <p:bg>
       <p:bgPr>
         <a:solidFill>
-          <a:srgbClr val="2C5F2D"/>
+          <a:srgbClr val="3D5A5B"/>
         </a:solidFill>
-        <a:effectLst/>
       </p:bgPr>
     </p:bg>
     <p:spTree>
@@ -2039,7 +2320,7 @@
           <a:bodyPr wrap="square" rtlCol="0" anchor="ctr"/>
           <a:lstStyle/>
           <a:p>
-            <a:pPr marL="0" indent="0" algn="ctr">
+            <a:pPr algn="ctr" indent="0" marL="0">
               <a:lnSpc>
                 <a:spcPct val="110000"/>
               </a:lnSpc>
@@ -2054,9 +2335,48 @@
                 <a:ea typeface="Georgia" pitchFamily="34" charset="-122"/>
                 <a:cs typeface="Georgia" pitchFamily="34" charset="-120"/>
               </a:rPr>
-              <a:t>A Three-Tier Framework to Divert Food Waste</a:t>
+              <a:t>Food Excess Analysis &amp; Policy Framework</a:t>
             </a:r>
             <a:endParaRPr lang="en-US" sz="3600" dirty="0"/>
+          </a:p>
+        </p:txBody>
+      </p:sp>
+      <p:sp>
+        <p:nvSpPr>
+          <p:cNvPr id="3" name="Text 1"/>
+          <p:cNvSpPr/>
+          <p:nvPr/>
+        </p:nvSpPr>
+        <p:spPr>
+          <a:xfrm>
+            <a:off x="914400" y="2560320"/>
+            <a:ext cx="7315200" cy="640080"/>
+          </a:xfrm>
+          <a:prstGeom prst="rect">
+            <a:avLst/>
+          </a:prstGeom>
+          <a:noFill/>
+          <a:ln/>
+        </p:spPr>
+        <p:txBody>
+          <a:bodyPr wrap="square" rtlCol="0" anchor="ctr"/>
+          <a:lstStyle/>
+          <a:p>
+            <a:pPr algn="ctr" indent="0" marL="0">
+              <a:buNone/>
+            </a:pPr>
+            <a:r>
+              <a:rPr lang="en-US" sz="1600" i="1" dirty="0">
+                <a:solidFill>
+                  <a:srgbClr val="8FB3A8"/>
+                </a:solidFill>
+                <a:latin typeface="Calibri" pitchFamily="34" charset="0"/>
+                <a:ea typeface="Calibri" pitchFamily="34" charset="-122"/>
+                <a:cs typeface="Calibri" pitchFamily="34" charset="-120"/>
+              </a:rPr>
+              <a:t>First causal evidence that bans without infrastructure fail — the Massachusetts model shows how to fix it</a:t>
+            </a:r>
+            <a:endParaRPr lang="en-US" sz="1600" dirty="0"/>
           </a:p>
         </p:txBody>
       </p:sp>
@@ -2075,17 +2395,10 @@
             <a:avLst/>
           </a:prstGeom>
           <a:solidFill>
-            <a:srgbClr val="97BC62"/>
+            <a:srgbClr val="8FB3A8"/>
           </a:solidFill>
           <a:ln/>
         </p:spPr>
-        <p:txBody>
-          <a:bodyPr/>
-          <a:lstStyle/>
-          <a:p>
-            <a:endParaRPr lang="en-IN"/>
-          </a:p>
-        </p:txBody>
       </p:sp>
       <p:sp>
         <p:nvSpPr>
@@ -2108,7 +2421,7 @@
           <a:bodyPr wrap="square" rtlCol="0" anchor="ctr"/>
           <a:lstStyle/>
           <a:p>
-            <a:pPr marL="0" indent="0" algn="ctr">
+            <a:pPr algn="ctr" indent="0" marL="0">
               <a:buNone/>
             </a:pPr>
             <a:r>
@@ -2140,9 +2453,8 @@
     <p:bg>
       <p:bgPr>
         <a:solidFill>
-          <a:srgbClr val="F5F5F5"/>
+          <a:srgbClr val="F8F6F3"/>
         </a:solidFill>
-        <a:effectLst/>
       </p:bgPr>
     </p:bg>
     <p:spTree>
@@ -2180,13 +2492,13 @@
           <a:bodyPr wrap="square" rtlCol="0" anchor="ctr"/>
           <a:lstStyle/>
           <a:p>
-            <a:pPr marL="0" indent="0">
+            <a:pPr indent="0" marL="0">
               <a:buNone/>
             </a:pPr>
             <a:r>
               <a:rPr lang="en-US" sz="3000" b="1" dirty="0">
                 <a:solidFill>
-                  <a:srgbClr val="2C5F2D"/>
+                  <a:srgbClr val="3D5A5B"/>
                 </a:solidFill>
                 <a:latin typeface="Georgia" pitchFamily="34" charset="0"/>
                 <a:ea typeface="Georgia" pitchFamily="34" charset="-122"/>
@@ -2200,14 +2512,14 @@
       </p:sp>
       <p:pic>
         <p:nvPicPr>
-          <p:cNvPr id="3" name="Image 0" descr="C:\Users\venka\OneDrive\Desktop\Class\Events\Datathon Spring 26\agent-pipeline\files\outputs\ml\charts\cluster_map.png"/>
+          <p:cNvPr id="3" name="Image 0" descr="C:\Users\venka\OneDrive\Desktop\Class\Events\Datathon Spring 26\agent-pipeline\files\outputs\ml\charts\cluster_map.png">    </p:cNvPr>
           <p:cNvPicPr>
             <a:picLocks noChangeAspect="1"/>
           </p:cNvPicPr>
           <p:nvPr/>
         </p:nvPicPr>
         <p:blipFill>
-          <a:blip r:embed="rId3"/>
+          <a:blip r:embed="rId1"/>
           <a:stretch>
             <a:fillRect/>
           </a:stretch>
@@ -2243,7 +2555,7 @@
           <a:bodyPr wrap="square" rtlCol="0" anchor="t"/>
           <a:lstStyle/>
           <a:p>
-            <a:pPr marL="0" indent="0">
+            <a:pPr indent="0" marL="0">
               <a:lnSpc>
                 <a:spcPct val="110000"/>
               </a:lnSpc>
@@ -2252,7 +2564,7 @@
             <a:r>
               <a:rPr lang="en-US" sz="1100" b="1" dirty="0">
                 <a:solidFill>
-                  <a:srgbClr val="F96167"/>
+                  <a:srgbClr val="C4836D"/>
                 </a:solidFill>
                 <a:latin typeface="Calibri" pitchFamily="34" charset="0"/>
                 <a:ea typeface="Calibri" pitchFamily="34" charset="-122"/>
@@ -2260,10 +2572,16 @@
               </a:rPr>
               <a:t>Landfill-Dependent (22 states): </a:t>
             </a:r>
+            <a:pPr indent="0" marL="0">
+              <a:lnSpc>
+                <a:spcPct val="110000"/>
+              </a:lnSpc>
+              <a:buNone/>
+            </a:pPr>
             <a:r>
               <a:rPr lang="en-US" sz="1000" dirty="0">
                 <a:solidFill>
-                  <a:srgbClr val="363636"/>
+                  <a:srgbClr val="2D3436"/>
                 </a:solidFill>
                 <a:latin typeface="Calibri" pitchFamily="34" charset="0"/>
                 <a:ea typeface="Calibri" pitchFamily="34" charset="-122"/>
@@ -2272,10 +2590,16 @@
               <a:t>53.9% avg landfill rate — highest priority targets
 </a:t>
             </a:r>
+            <a:pPr indent="0" marL="0">
+              <a:lnSpc>
+                <a:spcPct val="110000"/>
+              </a:lnSpc>
+              <a:buNone/>
+            </a:pPr>
             <a:r>
               <a:rPr lang="en-US" sz="1100" b="1" dirty="0">
                 <a:solidFill>
-                  <a:srgbClr val="2C5F2D"/>
+                  <a:srgbClr val="3D5A5B"/>
                 </a:solidFill>
                 <a:latin typeface="Calibri" pitchFamily="34" charset="0"/>
                 <a:ea typeface="Calibri" pitchFamily="34" charset="-122"/>
@@ -2283,10 +2607,16 @@
               </a:rPr>
               <a:t>Agricultural States (5): </a:t>
             </a:r>
+            <a:pPr indent="0" marL="0">
+              <a:lnSpc>
+                <a:spcPct val="110000"/>
+              </a:lnSpc>
+              <a:buNone/>
+            </a:pPr>
             <a:r>
               <a:rPr lang="en-US" sz="1000" dirty="0">
                 <a:solidFill>
-                  <a:srgbClr val="363636"/>
+                  <a:srgbClr val="2D3436"/>
                 </a:solidFill>
                 <a:latin typeface="Calibri" pitchFamily="34" charset="0"/>
                 <a:ea typeface="Calibri" pitchFamily="34" charset="-122"/>
@@ -2295,10 +2625,16 @@
               <a:t>20.7% rate — policy leaders
 </a:t>
             </a:r>
+            <a:pPr indent="0" marL="0">
+              <a:lnSpc>
+                <a:spcPct val="110000"/>
+              </a:lnSpc>
+              <a:buNone/>
+            </a:pPr>
             <a:r>
               <a:rPr lang="en-US" sz="1100" b="1" dirty="0">
                 <a:solidFill>
-                  <a:srgbClr val="065A82"/>
+                  <a:srgbClr val="4A7A8C"/>
                 </a:solidFill>
                 <a:latin typeface="Calibri" pitchFamily="34" charset="0"/>
                 <a:ea typeface="Calibri" pitchFamily="34" charset="-122"/>
@@ -2306,10 +2642,16 @@
               </a:rPr>
               <a:t>Mixed Economy (19): </a:t>
             </a:r>
+            <a:pPr indent="0" marL="0">
+              <a:lnSpc>
+                <a:spcPct val="110000"/>
+              </a:lnSpc>
+              <a:buNone/>
+            </a:pPr>
             <a:r>
               <a:rPr lang="en-US" sz="1000" dirty="0">
                 <a:solidFill>
-                  <a:srgbClr val="363636"/>
+                  <a:srgbClr val="2D3436"/>
                 </a:solidFill>
                 <a:latin typeface="Calibri" pitchFamily="34" charset="0"/>
                 <a:ea typeface="Calibri" pitchFamily="34" charset="-122"/>
@@ -2318,10 +2660,16 @@
               <a:t>43.4% rate — second priority tier
 </a:t>
             </a:r>
+            <a:pPr indent="0" marL="0">
+              <a:lnSpc>
+                <a:spcPct val="110000"/>
+              </a:lnSpc>
+              <a:buNone/>
+            </a:pPr>
             <a:r>
               <a:rPr lang="en-US" sz="1100" b="1" dirty="0">
                 <a:solidFill>
-                  <a:srgbClr val="97BC62"/>
+                  <a:srgbClr val="8FB3A8"/>
                 </a:solidFill>
                 <a:latin typeface="Calibri" pitchFamily="34" charset="0"/>
                 <a:ea typeface="Calibri" pitchFamily="34" charset="-122"/>
@@ -2329,10 +2677,16 @@
               </a:rPr>
               <a:t>Diversion Leaders (4): </a:t>
             </a:r>
+            <a:pPr indent="0" marL="0">
+              <a:lnSpc>
+                <a:spcPct val="110000"/>
+              </a:lnSpc>
+              <a:buNone/>
+            </a:pPr>
             <a:r>
               <a:rPr lang="en-US" sz="1000" dirty="0">
                 <a:solidFill>
-                  <a:srgbClr val="363636"/>
+                  <a:srgbClr val="2D3436"/>
                 </a:solidFill>
                 <a:latin typeface="Calibri" pitchFamily="34" charset="0"/>
                 <a:ea typeface="Calibri" pitchFamily="34" charset="-122"/>
@@ -2365,7 +2719,7 @@
           <a:bodyPr wrap="square" rtlCol="0" anchor="ctr"/>
           <a:lstStyle/>
           <a:p>
-            <a:pPr marL="0" indent="0">
+            <a:pPr indent="0" marL="0">
               <a:buNone/>
             </a:pPr>
             <a:r>
@@ -2377,7 +2731,7 @@
                 <a:ea typeface="Calibri" pitchFamily="34" charset="-122"/>
                 <a:cs typeface="Calibri" pitchFamily="34" charset="-120"/>
               </a:rPr>
-              <a:t>Source: ReFED Food Waste Monitor, 2024</a:t>
+              <a:t>Source: ReFED Food Waste Monitor, 2024 | Authors' analysis</a:t>
             </a:r>
             <a:endParaRPr lang="en-US" sz="800" dirty="0"/>
           </a:p>
@@ -2397,9 +2751,8 @@
     <p:bg>
       <p:bgPr>
         <a:solidFill>
-          <a:srgbClr val="2C5F2D"/>
+          <a:srgbClr val="3D5A5B"/>
         </a:solidFill>
-        <a:effectLst/>
       </p:bgPr>
     </p:bg>
     <p:spTree>
@@ -2437,7 +2790,7 @@
           <a:bodyPr wrap="square" rtlCol="0" anchor="ctr"/>
           <a:lstStyle/>
           <a:p>
-            <a:pPr marL="0" indent="0" algn="ctr">
+            <a:pPr algn="ctr" indent="0" marL="0">
               <a:buNone/>
             </a:pPr>
             <a:r>
@@ -2476,13 +2829,13 @@
           <a:bodyPr wrap="square" rtlCol="0" anchor="ctr"/>
           <a:lstStyle/>
           <a:p>
-            <a:pPr marL="0" indent="0" algn="ctr">
+            <a:pPr algn="ctr" indent="0" marL="0">
               <a:buNone/>
             </a:pPr>
             <a:r>
               <a:rPr lang="en-US" sz="1800" i="1" dirty="0">
                 <a:solidFill>
-                  <a:srgbClr val="97BC62"/>
+                  <a:srgbClr val="8FB3A8"/>
                 </a:solidFill>
                 <a:latin typeface="Calibri" pitchFamily="34" charset="0"/>
                 <a:ea typeface="Calibri" pitchFamily="34" charset="-122"/>
@@ -2509,17 +2862,10 @@
             <a:avLst/>
           </a:prstGeom>
           <a:solidFill>
-            <a:srgbClr val="97BC62"/>
+            <a:srgbClr val="8FB3A8"/>
           </a:solidFill>
           <a:ln/>
         </p:spPr>
-        <p:txBody>
-          <a:bodyPr/>
-          <a:lstStyle/>
-          <a:p>
-            <a:endParaRPr lang="en-IN"/>
-          </a:p>
-        </p:txBody>
       </p:sp>
     </p:spTree>
   </p:cSld>
@@ -2535,9 +2881,8 @@
     <p:bg>
       <p:bgPr>
         <a:solidFill>
-          <a:srgbClr val="F5F5F5"/>
+          <a:srgbClr val="F8F6F3"/>
         </a:solidFill>
-        <a:effectLst/>
       </p:bgPr>
     </p:bg>
     <p:spTree>
@@ -2575,13 +2920,13 @@
           <a:bodyPr wrap="square" rtlCol="0" anchor="ctr"/>
           <a:lstStyle/>
           <a:p>
-            <a:pPr marL="0" indent="0">
+            <a:pPr indent="0" marL="0">
               <a:buNone/>
             </a:pPr>
             <a:r>
               <a:rPr lang="en-US" sz="3000" b="1" dirty="0">
                 <a:solidFill>
-                  <a:srgbClr val="2C5F2D"/>
+                  <a:srgbClr val="3D5A5B"/>
                 </a:solidFill>
                 <a:latin typeface="Georgia" pitchFamily="34" charset="0"/>
                 <a:ea typeface="Georgia" pitchFamily="34" charset="-122"/>
@@ -2595,21 +2940,21 @@
       </p:sp>
       <p:pic>
         <p:nvPicPr>
-          <p:cNvPr id="3" name="Image 0" descr="C:\Users\venka\OneDrive\Desktop\Class\Events\Datathon Spring 26\agent-pipeline\files\outputs\causal\charts\event_study.png"/>
+          <p:cNvPr id="3" name="Image 0" descr="C:\Users\venka\OneDrive\Desktop\Class\Events\Datathon Spring 26\agent-pipeline\files\outputs\causal\charts\event_study.png">    </p:cNvPr>
           <p:cNvPicPr>
             <a:picLocks noChangeAspect="1"/>
           </p:cNvPicPr>
           <p:nvPr/>
         </p:nvPicPr>
         <p:blipFill>
-          <a:blip r:embed="rId3"/>
+          <a:blip r:embed="rId1"/>
           <a:stretch>
             <a:fillRect/>
           </a:stretch>
         </p:blipFill>
         <p:spPr>
           <a:xfrm>
-            <a:off x="228600" y="969101"/>
+            <a:off x="182880" y="777240"/>
             <a:ext cx="4754880" cy="3474720"/>
           </a:xfrm>
           <a:prstGeom prst="rect">
@@ -2634,22 +2979,15 @@
             </a:avLst>
           </a:prstGeom>
           <a:solidFill>
-            <a:srgbClr val="F5F5F5"/>
+            <a:srgbClr val="F8F6F3"/>
           </a:solidFill>
           <a:ln w="25400">
             <a:solidFill>
-              <a:srgbClr val="2C5F2D"/>
+              <a:srgbClr val="3D5A5B"/>
             </a:solidFill>
             <a:prstDash val="solid"/>
           </a:ln>
         </p:spPr>
-        <p:txBody>
-          <a:bodyPr/>
-          <a:lstStyle/>
-          <a:p>
-            <a:endParaRPr lang="en-IN"/>
-          </a:p>
-        </p:txBody>
       </p:sp>
       <p:sp>
         <p:nvSpPr>
@@ -2672,7 +3010,7 @@
           <a:bodyPr wrap="square" rtlCol="0" anchor="t"/>
           <a:lstStyle/>
           <a:p>
-            <a:pPr marL="0" indent="0">
+            <a:pPr indent="0" marL="0">
               <a:lnSpc>
                 <a:spcPct val="105000"/>
               </a:lnSpc>
@@ -2681,7 +3019,7 @@
             <a:r>
               <a:rPr lang="en-US" sz="1500" b="1" dirty="0">
                 <a:solidFill>
-                  <a:srgbClr val="2C5F2D"/>
+                  <a:srgbClr val="3D5A5B"/>
                 </a:solidFill>
                 <a:latin typeface="Georgia" pitchFamily="34" charset="0"/>
                 <a:ea typeface="Georgia" pitchFamily="34" charset="-122"/>
@@ -2690,10 +3028,16 @@
               <a:t>Difference-in-Differences
 </a:t>
             </a:r>
+            <a:pPr indent="0" marL="0">
+              <a:lnSpc>
+                <a:spcPct val="105000"/>
+              </a:lnSpc>
+              <a:buNone/>
+            </a:pPr>
             <a:r>
               <a:rPr lang="en-US" sz="2800" b="1" dirty="0">
                 <a:solidFill>
-                  <a:srgbClr val="F96167"/>
+                  <a:srgbClr val="C4836D"/>
                 </a:solidFill>
                 <a:latin typeface="Georgia" pitchFamily="34" charset="0"/>
                 <a:ea typeface="Georgia" pitchFamily="34" charset="-122"/>
@@ -2702,10 +3046,16 @@
               <a:t>β = +2.03 pp
 </a:t>
             </a:r>
+            <a:pPr indent="0" marL="0">
+              <a:lnSpc>
+                <a:spcPct val="105000"/>
+              </a:lnSpc>
+              <a:buNone/>
+            </a:pPr>
             <a:r>
               <a:rPr lang="en-US" sz="1100" dirty="0">
                 <a:solidFill>
-                  <a:srgbClr val="363636"/>
+                  <a:srgbClr val="2D3436"/>
                 </a:solidFill>
                 <a:latin typeface="Calibri" pitchFamily="34" charset="0"/>
                 <a:ea typeface="Calibri" pitchFamily="34" charset="-122"/>
@@ -2714,18 +3064,47 @@
               <a:t>on landfill rate
 </a:t>
             </a:r>
+            <a:pPr indent="0" marL="0">
+              <a:lnSpc>
+                <a:spcPct val="105000"/>
+              </a:lnSpc>
+              <a:buNone/>
+            </a:pPr>
             <a:r>
               <a:rPr lang="en-US" sz="1100" b="1" dirty="0">
                 <a:solidFill>
-                  <a:srgbClr val="363636"/>
-                </a:solidFill>
-                <a:latin typeface="Calibri" pitchFamily="34" charset="0"/>
-                <a:ea typeface="Calibri" pitchFamily="34" charset="-122"/>
-                <a:cs typeface="Calibri" pitchFamily="34" charset="-120"/>
-              </a:rPr>
-              <a:t>p = 0.008  |  R² = 0.989
+                  <a:srgbClr val="2D3436"/>
+                </a:solidFill>
+                <a:latin typeface="Calibri" pitchFamily="34" charset="0"/>
+                <a:ea typeface="Calibri" pitchFamily="34" charset="-122"/>
+                <a:cs typeface="Calibri" pitchFamily="34" charset="-120"/>
+              </a:rPr>
+              <a:t>p = 0.008  |  </a:t>
+            </a:r>
+            <a:pPr indent="0" marL="0">
+              <a:lnSpc>
+                <a:spcPct val="105000"/>
+              </a:lnSpc>
+              <a:buNone/>
+            </a:pPr>
+            <a:r>
+              <a:rPr lang="en-US" sz="1100" b="1" dirty="0">
+                <a:solidFill>
+                  <a:srgbClr val="2D3436"/>
+                </a:solidFill>
+                <a:latin typeface="Calibri" pitchFamily="34" charset="0"/>
+                <a:ea typeface="Calibri" pitchFamily="34" charset="-122"/>
+                <a:cs typeface="Calibri" pitchFamily="34" charset="-120"/>
+              </a:rPr>
+              <a:t>R² = 0.989
 </a:t>
             </a:r>
+            <a:pPr indent="0" marL="0">
+              <a:lnSpc>
+                <a:spcPct val="105000"/>
+              </a:lnSpc>
+              <a:buNone/>
+            </a:pPr>
             <a:r>
               <a:rPr lang="en-US" sz="1000" dirty="0">
                 <a:solidFill>
@@ -2741,18 +3120,30 @@
 15 years (2010–2024)
 </a:t>
             </a:r>
+            <a:pPr indent="0" marL="0">
+              <a:lnSpc>
+                <a:spcPct val="105000"/>
+              </a:lnSpc>
+              <a:buNone/>
+            </a:pPr>
             <a:r>
               <a:rPr lang="en-US" sz="1100" b="1" dirty="0">
                 <a:solidFill>
-                  <a:srgbClr val="2C5F2D"/>
-                </a:solidFill>
-                <a:latin typeface="Calibri" pitchFamily="34" charset="0"/>
-                <a:ea typeface="Calibri" pitchFamily="34" charset="-122"/>
-                <a:cs typeface="Calibri" pitchFamily="34" charset="-120"/>
-              </a:rPr>
-              <a:t>Pre-trends validated
+                  <a:srgbClr val="3D5A5B"/>
+                </a:solidFill>
+                <a:latin typeface="Calibri" pitchFamily="34" charset="0"/>
+                <a:ea typeface="Calibri" pitchFamily="34" charset="-122"/>
+                <a:cs typeface="Calibri" pitchFamily="34" charset="-120"/>
+              </a:rPr>
+              <a:t>Pre-trends validated ✓
 </a:t>
             </a:r>
+            <a:pPr indent="0" marL="0">
+              <a:lnSpc>
+                <a:spcPct val="105000"/>
+              </a:lnSpc>
+              <a:buNone/>
+            </a:pPr>
             <a:r>
               <a:rPr lang="en-US" sz="1000" dirty="0">
                 <a:solidFill>
@@ -2782,9 +3173,8 @@
     <p:bg>
       <p:bgPr>
         <a:solidFill>
-          <a:srgbClr val="F5F5F5"/>
+          <a:srgbClr val="F8F6F3"/>
         </a:solidFill>
-        <a:effectLst/>
       </p:bgPr>
     </p:bg>
     <p:spTree>
@@ -2822,13 +3212,13 @@
           <a:bodyPr wrap="square" rtlCol="0" anchor="ctr"/>
           <a:lstStyle/>
           <a:p>
-            <a:pPr marL="0" indent="0">
+            <a:pPr indent="0" marL="0">
               <a:buNone/>
             </a:pPr>
             <a:r>
               <a:rPr lang="en-US" sz="3000" b="1" dirty="0">
                 <a:solidFill>
-                  <a:srgbClr val="2C5F2D"/>
+                  <a:srgbClr val="3D5A5B"/>
                 </a:solidFill>
                 <a:latin typeface="Georgia" pitchFamily="34" charset="0"/>
                 <a:ea typeface="Georgia" pitchFamily="34" charset="-122"/>
@@ -2842,14 +3232,14 @@
       </p:sp>
       <p:pic>
         <p:nvPicPr>
-          <p:cNvPr id="3" name="Image 0" descr="C:\Users\venka\OneDrive\Desktop\Class\Events\Datathon Spring 26\agent-pipeline\files\outputs\causal\charts\synthetic_california.png"/>
+          <p:cNvPr id="3" name="Image 0" descr="C:\Users\venka\OneDrive\Desktop\Class\Events\Datathon Spring 26\agent-pipeline\files\outputs\causal\charts\synthetic_california.png">    </p:cNvPr>
           <p:cNvPicPr>
             <a:picLocks noChangeAspect="1"/>
           </p:cNvPicPr>
           <p:nvPr/>
         </p:nvPicPr>
         <p:blipFill>
-          <a:blip r:embed="rId3"/>
+          <a:blip r:embed="rId1"/>
           <a:stretch>
             <a:fillRect/>
           </a:stretch>
@@ -2866,6 +3256,28 @@
       </p:pic>
       <p:sp>
         <p:nvSpPr>
+          <p:cNvPr id="4" name="Shape 1"/>
+          <p:cNvSpPr/>
+          <p:nvPr/>
+        </p:nvSpPr>
+        <p:spPr>
+          <a:xfrm>
+            <a:off x="6400800" y="3474720"/>
+            <a:ext cx="2468880" cy="914400"/>
+          </a:xfrm>
+          <a:prstGeom prst="roundRect">
+            <a:avLst>
+              <a:gd name="adj" fmla="val 10000"/>
+            </a:avLst>
+          </a:prstGeom>
+          <a:solidFill>
+            <a:srgbClr val="C5D5CD"/>
+          </a:solidFill>
+          <a:ln/>
+        </p:spPr>
+      </p:sp>
+      <p:sp>
+        <p:nvSpPr>
           <p:cNvPr id="5" name="Text 2"/>
           <p:cNvSpPr/>
           <p:nvPr/>
@@ -2878,33 +3290,20 @@
           <a:prstGeom prst="rect">
             <a:avLst/>
           </a:prstGeom>
-          <a:ln/>
-        </p:spPr>
-        <p:style>
-          <a:lnRef idx="2">
-            <a:schemeClr val="accent3"/>
-          </a:lnRef>
-          <a:fillRef idx="1">
-            <a:schemeClr val="lt1"/>
-          </a:fillRef>
-          <a:effectRef idx="0">
-            <a:schemeClr val="accent3"/>
-          </a:effectRef>
-          <a:fontRef idx="minor">
-            <a:schemeClr val="dk1"/>
-          </a:fontRef>
-        </p:style>
+          <a:noFill/>
+          <a:ln/>
+        </p:spPr>
         <p:txBody>
           <a:bodyPr wrap="square" rtlCol="0" anchor="ctr"/>
           <a:lstStyle/>
           <a:p>
-            <a:pPr marL="0" indent="0" algn="ctr">
+            <a:pPr algn="ctr" indent="0" marL="0">
               <a:buNone/>
             </a:pPr>
             <a:r>
               <a:rPr lang="en-US" sz="1000" dirty="0">
                 <a:solidFill>
-                  <a:srgbClr val="363636"/>
+                  <a:srgbClr val="2D3436"/>
                 </a:solidFill>
                 <a:latin typeface="Calibri" pitchFamily="34" charset="0"/>
                 <a:ea typeface="Calibri" pitchFamily="34" charset="-122"/>
@@ -2912,10 +3311,13 @@
               </a:rPr>
               <a:t>Post-2022 gap: </a:t>
             </a:r>
+            <a:pPr algn="ctr" indent="0" marL="0">
+              <a:buNone/>
+            </a:pPr>
             <a:r>
               <a:rPr lang="en-US" sz="1400" b="1" dirty="0">
                 <a:solidFill>
-                  <a:srgbClr val="F96167"/>
+                  <a:srgbClr val="C4836D"/>
                 </a:solidFill>
                 <a:latin typeface="Georgia" pitchFamily="34" charset="0"/>
                 <a:ea typeface="Georgia" pitchFamily="34" charset="-122"/>
@@ -2923,10 +3325,13 @@
               </a:rPr>
               <a:t>+2.83 pp</a:t>
             </a:r>
+            <a:pPr algn="ctr" indent="0" marL="0">
+              <a:buNone/>
+            </a:pPr>
             <a:endParaRPr lang="en-US" sz="1000" dirty="0"/>
           </a:p>
           <a:p>
-            <a:pPr marL="0" indent="0" algn="ctr">
+            <a:pPr algn="ctr" indent="0" marL="0">
               <a:buNone/>
             </a:pPr>
             <a:r>
@@ -2958,9 +3363,8 @@
     <p:bg>
       <p:bgPr>
         <a:solidFill>
-          <a:srgbClr val="2C5F2D"/>
+          <a:srgbClr val="3D5A5B"/>
         </a:solidFill>
-        <a:effectLst/>
       </p:bgPr>
     </p:bg>
     <p:spTree>
@@ -2998,7 +3402,7 @@
           <a:bodyPr wrap="square" rtlCol="0" anchor="ctr"/>
           <a:lstStyle/>
           <a:p>
-            <a:pPr marL="0" indent="0" algn="ctr">
+            <a:pPr algn="ctr" indent="0" marL="0">
               <a:buNone/>
             </a:pPr>
             <a:r>
@@ -3033,17 +3437,10 @@
             </a:avLst>
           </a:prstGeom>
           <a:solidFill>
-            <a:srgbClr val="234A24"/>
+            <a:srgbClr val="2F4A4C"/>
           </a:solidFill>
           <a:ln/>
         </p:spPr>
-        <p:txBody>
-          <a:bodyPr/>
-          <a:lstStyle/>
-          <a:p>
-            <a:endParaRPr lang="en-IN"/>
-          </a:p>
-        </p:txBody>
       </p:sp>
       <p:sp>
         <p:nvSpPr>
@@ -3066,13 +3463,13 @@
           <a:bodyPr wrap="square" rtlCol="0" anchor="ctr"/>
           <a:lstStyle/>
           <a:p>
-            <a:pPr marL="0" indent="0" algn="ctr">
+            <a:pPr algn="ctr" indent="0" marL="0">
               <a:buNone/>
             </a:pPr>
             <a:r>
               <a:rPr lang="en-US" sz="1600" b="1" dirty="0">
                 <a:solidFill>
-                  <a:srgbClr val="97BC62"/>
+                  <a:srgbClr val="8FB3A8"/>
                 </a:solidFill>
                 <a:latin typeface="Georgia" pitchFamily="34" charset="0"/>
                 <a:ea typeface="Georgia" pitchFamily="34" charset="-122"/>
@@ -3105,7 +3502,7 @@
           <a:bodyPr wrap="square" rtlCol="0" anchor="t"/>
           <a:lstStyle/>
           <a:p>
-            <a:pPr marL="0" indent="0">
+            <a:pPr indent="0" marL="0">
               <a:lnSpc>
                 <a:spcPct val="115000"/>
               </a:lnSpc>
@@ -3123,6 +3520,12 @@
               <a:t>Date Label Standardization
 </a:t>
             </a:r>
+            <a:pPr indent="0" marL="0">
+              <a:lnSpc>
+                <a:spcPct val="115000"/>
+              </a:lnSpc>
+              <a:buNone/>
+            </a:pPr>
             <a:r>
               <a:rPr lang="en-US" sz="900" dirty="0">
                 <a:solidFill>
@@ -3136,39 +3539,31 @@
 Most cost-effective single intervention
 </a:t>
             </a:r>
-            <a:r>
-              <a:rPr lang="en-US" sz="1200" b="1" dirty="0">
-                <a:solidFill>
-                  <a:srgbClr val="FFFFFF"/>
-                </a:solidFill>
-                <a:latin typeface="Calibri" pitchFamily="34" charset="0"/>
-                <a:ea typeface="Calibri" pitchFamily="34" charset="-122"/>
-                <a:cs typeface="Calibri" pitchFamily="34" charset="-120"/>
-              </a:rPr>
-              <a:t>National Organic Waste Mandate
-</a:t>
-            </a:r>
-            <a:r>
-              <a:rPr lang="en-US" sz="900" dirty="0">
-                <a:solidFill>
-                  <a:srgbClr val="CCCCCC"/>
-                </a:solidFill>
-                <a:latin typeface="Calibri" pitchFamily="34" charset="0"/>
-                <a:ea typeface="Calibri" pitchFamily="34" charset="-122"/>
-                <a:cs typeface="Calibri" pitchFamily="34" charset="-120"/>
-              </a:rPr>
-              <a:t>779K tons/yr shifted</a:t>
-            </a:r>
-            <a:endParaRPr lang="en-US" sz="1200" dirty="0"/>
-          </a:p>
-          <a:p>
-            <a:pPr marL="0" indent="0">
+            <a:pPr indent="0" marL="0">
               <a:lnSpc>
                 <a:spcPct val="115000"/>
               </a:lnSpc>
               <a:buNone/>
             </a:pPr>
             <a:r>
+              <a:rPr lang="en-US" sz="1200" b="1" dirty="0">
+                <a:solidFill>
+                  <a:srgbClr val="FFFFFF"/>
+                </a:solidFill>
+                <a:latin typeface="Calibri" pitchFamily="34" charset="0"/>
+                <a:ea typeface="Calibri" pitchFamily="34" charset="-122"/>
+                <a:cs typeface="Calibri" pitchFamily="34" charset="-120"/>
+              </a:rPr>
+              <a:t>National Organic Waste Mandate
+</a:t>
+            </a:r>
+            <a:pPr indent="0" marL="0">
+              <a:lnSpc>
+                <a:spcPct val="115000"/>
+              </a:lnSpc>
+              <a:buNone/>
+            </a:pPr>
+            <a:r>
               <a:rPr lang="en-US" sz="900" dirty="0">
                 <a:solidFill>
                   <a:srgbClr val="CCCCCC"/>
@@ -3177,12 +3572,32 @@
                 <a:ea typeface="Calibri" pitchFamily="34" charset="-122"/>
                 <a:cs typeface="Calibri" pitchFamily="34" charset="-120"/>
               </a:rPr>
+              <a:t>779K tons/yr shifted</a:t>
+            </a:r>
+            <a:endParaRPr lang="en-US" sz="1200" dirty="0"/>
+          </a:p>
+          <a:p>
+            <a:pPr indent="0" marL="0">
+              <a:lnSpc>
+                <a:spcPct val="115000"/>
+              </a:lnSpc>
+              <a:buNone/>
+            </a:pPr>
+            <a:r>
+              <a:rPr lang="en-US" sz="900" dirty="0">
+                <a:solidFill>
+                  <a:srgbClr val="CCCCCC"/>
+                </a:solidFill>
+                <a:latin typeface="Calibri" pitchFamily="34" charset="0"/>
+                <a:ea typeface="Calibri" pitchFamily="34" charset="-122"/>
+                <a:cs typeface="Calibri" pitchFamily="34" charset="-120"/>
+              </a:rPr>
               <a:t>Paired with infrastructure investment</a:t>
             </a:r>
             <a:endParaRPr lang="en-US" sz="1200" dirty="0"/>
           </a:p>
           <a:p>
-            <a:pPr marL="0" indent="0">
+            <a:pPr indent="0" marL="0">
               <a:lnSpc>
                 <a:spcPct val="115000"/>
               </a:lnSpc>
@@ -3220,17 +3635,10 @@
             </a:avLst>
           </a:prstGeom>
           <a:solidFill>
-            <a:srgbClr val="234A24"/>
+            <a:srgbClr val="2F4A4C"/>
           </a:solidFill>
           <a:ln/>
         </p:spPr>
-        <p:txBody>
-          <a:bodyPr/>
-          <a:lstStyle/>
-          <a:p>
-            <a:endParaRPr lang="en-IN"/>
-          </a:p>
-        </p:txBody>
       </p:sp>
       <p:sp>
         <p:nvSpPr>
@@ -3253,13 +3661,13 @@
           <a:bodyPr wrap="square" rtlCol="0" anchor="ctr"/>
           <a:lstStyle/>
           <a:p>
-            <a:pPr marL="0" indent="0" algn="ctr">
+            <a:pPr algn="ctr" indent="0" marL="0">
               <a:buNone/>
             </a:pPr>
             <a:r>
               <a:rPr lang="en-US" sz="1600" b="1" dirty="0">
                 <a:solidFill>
-                  <a:srgbClr val="97BC62"/>
+                  <a:srgbClr val="8FB3A8"/>
                 </a:solidFill>
                 <a:latin typeface="Georgia" pitchFamily="34" charset="0"/>
                 <a:ea typeface="Georgia" pitchFamily="34" charset="-122"/>
@@ -3292,7 +3700,7 @@
           <a:bodyPr wrap="square" rtlCol="0" anchor="t"/>
           <a:lstStyle/>
           <a:p>
-            <a:pPr marL="0" indent="0">
+            <a:pPr indent="0" marL="0">
               <a:lnSpc>
                 <a:spcPct val="115000"/>
               </a:lnSpc>
@@ -3310,6 +3718,12 @@
               <a:t>Infrastructure-Backed Bans
 </a:t>
             </a:r>
+            <a:pPr indent="0" marL="0">
+              <a:lnSpc>
+                <a:spcPct val="115000"/>
+              </a:lnSpc>
+              <a:buNone/>
+            </a:pPr>
             <a:r>
               <a:rPr lang="en-US" sz="900" dirty="0">
                 <a:solidFill>
@@ -3324,39 +3738,31 @@
 22 'Landfill-Dependent' states first
 </a:t>
             </a:r>
-            <a:r>
-              <a:rPr lang="en-US" sz="1200" b="1" dirty="0">
-                <a:solidFill>
-                  <a:srgbClr val="FFFFFF"/>
-                </a:solidFill>
-                <a:latin typeface="Calibri" pitchFamily="34" charset="0"/>
-                <a:ea typeface="Calibri" pitchFamily="34" charset="-122"/>
-                <a:cs typeface="Calibri" pitchFamily="34" charset="-120"/>
-              </a:rPr>
-              <a:t>Donation &amp; Composting Infra
-</a:t>
-            </a:r>
-            <a:r>
-              <a:rPr lang="en-US" sz="900" dirty="0">
-                <a:solidFill>
-                  <a:srgbClr val="CCCCCC"/>
-                </a:solidFill>
-                <a:latin typeface="Calibri" pitchFamily="34" charset="0"/>
-                <a:ea typeface="Calibri" pitchFamily="34" charset="-122"/>
-                <a:cs typeface="Calibri" pitchFamily="34" charset="-120"/>
-              </a:rPr>
-              <a:t>Close $141B residential gap</a:t>
-            </a:r>
-            <a:endParaRPr lang="en-US" sz="1200" dirty="0"/>
-          </a:p>
-          <a:p>
-            <a:pPr marL="0" indent="0">
+            <a:pPr indent="0" marL="0">
               <a:lnSpc>
                 <a:spcPct val="115000"/>
               </a:lnSpc>
               <a:buNone/>
             </a:pPr>
             <a:r>
+              <a:rPr lang="en-US" sz="1200" b="1" dirty="0">
+                <a:solidFill>
+                  <a:srgbClr val="FFFFFF"/>
+                </a:solidFill>
+                <a:latin typeface="Calibri" pitchFamily="34" charset="0"/>
+                <a:ea typeface="Calibri" pitchFamily="34" charset="-122"/>
+                <a:cs typeface="Calibri" pitchFamily="34" charset="-120"/>
+              </a:rPr>
+              <a:t>Donation &amp; Composting Infra
+</a:t>
+            </a:r>
+            <a:pPr indent="0" marL="0">
+              <a:lnSpc>
+                <a:spcPct val="115000"/>
+              </a:lnSpc>
+              <a:buNone/>
+            </a:pPr>
+            <a:r>
               <a:rPr lang="en-US" sz="900" dirty="0">
                 <a:solidFill>
                   <a:srgbClr val="CCCCCC"/>
@@ -3365,12 +3771,32 @@
                 <a:ea typeface="Calibri" pitchFamily="34" charset="-122"/>
                 <a:cs typeface="Calibri" pitchFamily="34" charset="-120"/>
               </a:rPr>
+              <a:t>Close $141B residential gap</a:t>
+            </a:r>
+            <a:endParaRPr lang="en-US" sz="1200" dirty="0"/>
+          </a:p>
+          <a:p>
+            <a:pPr indent="0" marL="0">
+              <a:lnSpc>
+                <a:spcPct val="115000"/>
+              </a:lnSpc>
+              <a:buNone/>
+            </a:pPr>
+            <a:r>
+              <a:rPr lang="en-US" sz="900" dirty="0">
+                <a:solidFill>
+                  <a:srgbClr val="CCCCCC"/>
+                </a:solidFill>
+                <a:latin typeface="Calibri" pitchFamily="34" charset="0"/>
+                <a:ea typeface="Calibri" pitchFamily="34" charset="-122"/>
+                <a:cs typeface="Calibri" pitchFamily="34" charset="-120"/>
+              </a:rPr>
               <a:t>Curbside organics collection</a:t>
             </a:r>
             <a:endParaRPr lang="en-US" sz="1200" dirty="0"/>
           </a:p>
           <a:p>
-            <a:pPr marL="0" indent="0">
+            <a:pPr indent="0" marL="0">
               <a:lnSpc>
                 <a:spcPct val="115000"/>
               </a:lnSpc>
@@ -3408,17 +3834,10 @@
             </a:avLst>
           </a:prstGeom>
           <a:solidFill>
-            <a:srgbClr val="234A24"/>
+            <a:srgbClr val="2F4A4C"/>
           </a:solidFill>
           <a:ln/>
         </p:spPr>
-        <p:txBody>
-          <a:bodyPr/>
-          <a:lstStyle/>
-          <a:p>
-            <a:endParaRPr lang="en-IN"/>
-          </a:p>
-        </p:txBody>
       </p:sp>
       <p:sp>
         <p:nvSpPr>
@@ -3441,13 +3860,13 @@
           <a:bodyPr wrap="square" rtlCol="0" anchor="ctr"/>
           <a:lstStyle/>
           <a:p>
-            <a:pPr marL="0" indent="0" algn="ctr">
+            <a:pPr algn="ctr" indent="0" marL="0">
               <a:buNone/>
             </a:pPr>
             <a:r>
               <a:rPr lang="en-US" sz="1600" b="1" dirty="0">
                 <a:solidFill>
-                  <a:srgbClr val="97BC62"/>
+                  <a:srgbClr val="8FB3A8"/>
                 </a:solidFill>
                 <a:latin typeface="Georgia" pitchFamily="34" charset="0"/>
                 <a:ea typeface="Georgia" pitchFamily="34" charset="-122"/>
@@ -3480,7 +3899,7 @@
           <a:bodyPr wrap="square" rtlCol="0" anchor="t"/>
           <a:lstStyle/>
           <a:p>
-            <a:pPr marL="0" indent="0">
+            <a:pPr indent="0" marL="0">
               <a:lnSpc>
                 <a:spcPct val="115000"/>
               </a:lnSpc>
@@ -3498,6 +3917,12 @@
               <a:t>Residential
 </a:t>
             </a:r>
+            <a:pPr indent="0" marL="0">
+              <a:lnSpc>
+                <a:spcPct val="115000"/>
+              </a:lnSpc>
+              <a:buNone/>
+            </a:pPr>
             <a:r>
               <a:rPr lang="en-US" sz="900" dirty="0">
                 <a:solidFill>
@@ -3511,6 +3936,12 @@
 33% of surplus, $141B, 0 donations
 </a:t>
             </a:r>
+            <a:pPr indent="0" marL="0">
+              <a:lnSpc>
+                <a:spcPct val="115000"/>
+              </a:lnSpc>
+              <a:buNone/>
+            </a:pPr>
             <a:r>
               <a:rPr lang="en-US" sz="1200" b="1" dirty="0">
                 <a:solidFill>
@@ -3523,6 +3954,12 @@
               <a:t>Foodservice
 </a:t>
             </a:r>
+            <a:pPr indent="0" marL="0">
+              <a:lnSpc>
+                <a:spcPct val="115000"/>
+              </a:lnSpc>
+              <a:buNone/>
+            </a:pPr>
             <a:r>
               <a:rPr lang="en-US" sz="900" dirty="0">
                 <a:solidFill>
@@ -3536,6 +3973,12 @@
 42% of landfill, 18% of surplus
 </a:t>
             </a:r>
+            <a:pPr indent="0" marL="0">
+              <a:lnSpc>
+                <a:spcPct val="115000"/>
+              </a:lnSpc>
+              <a:buNone/>
+            </a:pPr>
             <a:r>
               <a:rPr lang="en-US" sz="1200" b="1" dirty="0">
                 <a:solidFill>
@@ -3548,6 +3991,12 @@
               <a:t>Farm
 </a:t>
             </a:r>
+            <a:pPr indent="0" marL="0">
+              <a:lnSpc>
+                <a:spcPct val="115000"/>
+              </a:lnSpc>
+              <a:buNone/>
+            </a:pPr>
             <a:r>
               <a:rPr lang="en-US" sz="900" dirty="0">
                 <a:solidFill>
@@ -3562,7 +4011,7 @@
             <a:endParaRPr lang="en-US" sz="1200" dirty="0"/>
           </a:p>
           <a:p>
-            <a:pPr marL="0" indent="0">
+            <a:pPr indent="0" marL="0">
               <a:lnSpc>
                 <a:spcPct val="115000"/>
               </a:lnSpc>
@@ -3597,9 +4046,8 @@
     <p:bg>
       <p:bgPr>
         <a:solidFill>
-          <a:srgbClr val="F5F5F5"/>
+          <a:srgbClr val="F8F6F3"/>
         </a:solidFill>
-        <a:effectLst/>
       </p:bgPr>
     </p:bg>
     <p:spTree>
@@ -3637,13 +4085,13 @@
           <a:bodyPr wrap="square" rtlCol="0" anchor="ctr"/>
           <a:lstStyle/>
           <a:p>
-            <a:pPr marL="0" indent="0">
+            <a:pPr indent="0" marL="0">
               <a:buNone/>
             </a:pPr>
             <a:r>
               <a:rPr lang="en-US" sz="3000" b="1" dirty="0">
                 <a:solidFill>
-                  <a:srgbClr val="2C5F2D"/>
+                  <a:srgbClr val="3D5A5B"/>
                 </a:solidFill>
                 <a:latin typeface="Georgia" pitchFamily="34" charset="0"/>
                 <a:ea typeface="Georgia" pitchFamily="34" charset="-122"/>
@@ -3657,14 +4105,14 @@
       </p:sp>
       <p:pic>
         <p:nvPicPr>
-          <p:cNvPr id="3" name="Image 0" descr="C:\Users\venka\OneDrive\Desktop\Class\Events\Datathon Spring 26\agent-pipeline\files\outputs\ml\charts\scenario_comparison.png"/>
+          <p:cNvPr id="3" name="Image 0" descr="C:\Users\venka\OneDrive\Desktop\Class\Events\Datathon Spring 26\agent-pipeline\files\outputs\ml\charts\scenario_comparison.png">    </p:cNvPr>
           <p:cNvPicPr>
             <a:picLocks noChangeAspect="1"/>
           </p:cNvPicPr>
           <p:nvPr/>
         </p:nvPicPr>
         <p:blipFill>
-          <a:blip r:embed="rId3"/>
+          <a:blip r:embed="rId1"/>
           <a:stretch>
             <a:fillRect/>
           </a:stretch>
@@ -3696,17 +4144,10 @@
             </a:avLst>
           </a:prstGeom>
           <a:solidFill>
-            <a:srgbClr val="A7BEAE"/>
+            <a:srgbClr val="C5D5CD"/>
           </a:solidFill>
           <a:ln/>
         </p:spPr>
-        <p:txBody>
-          <a:bodyPr/>
-          <a:lstStyle/>
-          <a:p>
-            <a:endParaRPr lang="en-IN"/>
-          </a:p>
-        </p:txBody>
       </p:sp>
       <p:sp>
         <p:nvSpPr>
@@ -3729,13 +4170,13 @@
           <a:bodyPr wrap="square" rtlCol="0" anchor="t"/>
           <a:lstStyle/>
           <a:p>
-            <a:pPr marL="0" indent="0">
+            <a:pPr indent="0" marL="0">
               <a:buNone/>
             </a:pPr>
             <a:r>
               <a:rPr lang="en-US" sz="1400" b="1" dirty="0">
                 <a:solidFill>
-                  <a:srgbClr val="2C5F2D"/>
+                  <a:srgbClr val="3D5A5B"/>
                 </a:solidFill>
                 <a:latin typeface="Georgia" pitchFamily="34" charset="0"/>
                 <a:ea typeface="Georgia" pitchFamily="34" charset="-122"/>
@@ -3744,10 +4185,13 @@
               <a:t>Combined Impact
 </a:t>
             </a:r>
+            <a:pPr indent="0" marL="0">
+              <a:buNone/>
+            </a:pPr>
             <a:r>
               <a:rPr lang="en-US" sz="1800" b="1" dirty="0">
                 <a:solidFill>
-                  <a:srgbClr val="2C5F2D"/>
+                  <a:srgbClr val="3D5A5B"/>
                 </a:solidFill>
                 <a:latin typeface="Georgia" pitchFamily="34" charset="0"/>
                 <a:ea typeface="Georgia" pitchFamily="34" charset="-122"/>
@@ -3756,10 +4200,13 @@
               <a:t>1,023,775 tons/yr
 </a:t>
             </a:r>
+            <a:pPr indent="0" marL="0">
+              <a:buNone/>
+            </a:pPr>
             <a:r>
               <a:rPr lang="en-US" sz="1000" dirty="0">
                 <a:solidFill>
-                  <a:srgbClr val="363636"/>
+                  <a:srgbClr val="2D3436"/>
                 </a:solidFill>
                 <a:latin typeface="Calibri" pitchFamily="34" charset="0"/>
                 <a:ea typeface="Calibri" pitchFamily="34" charset="-122"/>
@@ -3768,10 +4215,13 @@
               <a:t>diverted from landfills
 </a:t>
             </a:r>
+            <a:pPr indent="0" marL="0">
+              <a:buNone/>
+            </a:pPr>
             <a:r>
               <a:rPr lang="en-US" sz="1100" dirty="0">
                 <a:solidFill>
-                  <a:srgbClr val="363636"/>
+                  <a:srgbClr val="2D3436"/>
                 </a:solidFill>
                 <a:latin typeface="Calibri" pitchFamily="34" charset="0"/>
                 <a:ea typeface="Calibri" pitchFamily="34" charset="-122"/>
@@ -3782,6 +4232,9 @@
 $6.37B economic value
 </a:t>
             </a:r>
+            <a:pPr indent="0" marL="0">
+              <a:buNone/>
+            </a:pPr>
             <a:r>
               <a:rPr lang="en-US" sz="900" i="1" dirty="0">
                 <a:solidFill>
@@ -3818,7 +4271,7 @@
           <a:bodyPr wrap="square" rtlCol="0" anchor="ctr"/>
           <a:lstStyle/>
           <a:p>
-            <a:pPr marL="0" indent="0">
+            <a:pPr indent="0" marL="0">
               <a:buNone/>
             </a:pPr>
             <a:r>
@@ -3850,9 +4303,8 @@
     <p:bg>
       <p:bgPr>
         <a:solidFill>
-          <a:srgbClr val="F5F5F5"/>
+          <a:srgbClr val="F8F6F3"/>
         </a:solidFill>
-        <a:effectLst/>
       </p:bgPr>
     </p:bg>
     <p:spTree>
@@ -3890,13 +4342,13 @@
           <a:bodyPr wrap="square" rtlCol="0" anchor="ctr"/>
           <a:lstStyle/>
           <a:p>
-            <a:pPr marL="0" indent="0">
+            <a:pPr indent="0" marL="0">
               <a:buNone/>
             </a:pPr>
             <a:r>
               <a:rPr lang="en-US" sz="3000" b="1" dirty="0">
                 <a:solidFill>
-                  <a:srgbClr val="2C5F2D"/>
+                  <a:srgbClr val="3D5A5B"/>
                 </a:solidFill>
                 <a:latin typeface="Georgia" pitchFamily="34" charset="0"/>
                 <a:ea typeface="Georgia" pitchFamily="34" charset="-122"/>
@@ -3925,17 +4377,10 @@
             </a:avLst>
           </a:prstGeom>
           <a:solidFill>
-            <a:srgbClr val="A7BEAE"/>
+            <a:srgbClr val="C5D5CD"/>
           </a:solidFill>
           <a:ln/>
         </p:spPr>
-        <p:txBody>
-          <a:bodyPr/>
-          <a:lstStyle/>
-          <a:p>
-            <a:endParaRPr lang="en-IN"/>
-          </a:p>
-        </p:txBody>
       </p:sp>
       <p:sp>
         <p:nvSpPr>
@@ -3958,35 +4403,27 @@
           <a:bodyPr wrap="square" rtlCol="0" anchor="ctr"/>
           <a:lstStyle/>
           <a:p>
-            <a:pPr marL="0" indent="0">
-              <a:buNone/>
-            </a:pPr>
-            <a:r>
-              <a:rPr lang="en-US" sz="1100" b="1" dirty="0" err="1">
-                <a:solidFill>
-                  <a:srgbClr val="2C5F2D"/>
-                </a:solidFill>
-                <a:latin typeface="Calibri" pitchFamily="34" charset="0"/>
-                <a:ea typeface="Calibri" pitchFamily="34" charset="-122"/>
-                <a:cs typeface="Calibri" pitchFamily="34" charset="-120"/>
-              </a:rPr>
-              <a:t>DiD</a:t>
-            </a:r>
+            <a:pPr indent="0" marL="0">
+              <a:buNone/>
+            </a:pPr>
             <a:r>
               <a:rPr lang="en-US" sz="1100" b="1" dirty="0">
                 <a:solidFill>
-                  <a:srgbClr val="2C5F2D"/>
-                </a:solidFill>
-                <a:latin typeface="Calibri" pitchFamily="34" charset="0"/>
-                <a:ea typeface="Calibri" pitchFamily="34" charset="-122"/>
-                <a:cs typeface="Calibri" pitchFamily="34" charset="-120"/>
-              </a:rPr>
-              <a:t> Analysis:  </a:t>
-            </a:r>
+                  <a:srgbClr val="3D5A5B"/>
+                </a:solidFill>
+                <a:latin typeface="Calibri" pitchFamily="34" charset="0"/>
+                <a:ea typeface="Calibri" pitchFamily="34" charset="-122"/>
+                <a:cs typeface="Calibri" pitchFamily="34" charset="-120"/>
+              </a:rPr>
+              <a:t>Our DiD Analysis:  </a:t>
+            </a:r>
+            <a:pPr indent="0" marL="0">
+              <a:buNone/>
+            </a:pPr>
             <a:r>
               <a:rPr lang="en-US" sz="1000" dirty="0">
                 <a:solidFill>
-                  <a:srgbClr val="363636"/>
+                  <a:srgbClr val="2D3436"/>
                 </a:solidFill>
                 <a:latin typeface="Calibri" pitchFamily="34" charset="0"/>
                 <a:ea typeface="Calibri" pitchFamily="34" charset="-122"/>
@@ -4015,17 +4452,10 @@
             </a:avLst>
           </a:prstGeom>
           <a:solidFill>
-            <a:srgbClr val="E8F0E8"/>
+            <a:srgbClr val="E8EEEB"/>
           </a:solidFill>
           <a:ln/>
         </p:spPr>
-        <p:txBody>
-          <a:bodyPr/>
-          <a:lstStyle/>
-          <a:p>
-            <a:endParaRPr lang="en-IN"/>
-          </a:p>
-        </p:txBody>
       </p:sp>
       <p:sp>
         <p:nvSpPr>
@@ -4048,13 +4478,13 @@
           <a:bodyPr wrap="square" rtlCol="0" anchor="ctr"/>
           <a:lstStyle/>
           <a:p>
-            <a:pPr marL="0" indent="0">
+            <a:pPr indent="0" marL="0">
               <a:buNone/>
             </a:pPr>
             <a:r>
               <a:rPr lang="en-US" sz="1100" b="1" dirty="0">
                 <a:solidFill>
-                  <a:srgbClr val="2C5F2D"/>
+                  <a:srgbClr val="3D5A5B"/>
                 </a:solidFill>
                 <a:latin typeface="Calibri" pitchFamily="34" charset="0"/>
                 <a:ea typeface="Calibri" pitchFamily="34" charset="-122"/>
@@ -4062,10 +4492,13 @@
               </a:rPr>
               <a:t>UCSD / Science (2024):  </a:t>
             </a:r>
+            <a:pPr indent="0" marL="0">
+              <a:buNone/>
+            </a:pPr>
             <a:r>
               <a:rPr lang="en-US" sz="1000" dirty="0">
                 <a:solidFill>
-                  <a:srgbClr val="363636"/>
+                  <a:srgbClr val="2D3436"/>
                 </a:solidFill>
                 <a:latin typeface="Calibri" pitchFamily="34" charset="0"/>
                 <a:ea typeface="Calibri" pitchFamily="34" charset="-122"/>
@@ -4094,17 +4527,10 @@
             </a:avLst>
           </a:prstGeom>
           <a:solidFill>
-            <a:srgbClr val="A7BEAE"/>
+            <a:srgbClr val="C5D5CD"/>
           </a:solidFill>
           <a:ln/>
         </p:spPr>
-        <p:txBody>
-          <a:bodyPr/>
-          <a:lstStyle/>
-          <a:p>
-            <a:endParaRPr lang="en-IN"/>
-          </a:p>
-        </p:txBody>
       </p:sp>
       <p:sp>
         <p:nvSpPr>
@@ -4127,13 +4553,13 @@
           <a:bodyPr wrap="square" rtlCol="0" anchor="ctr"/>
           <a:lstStyle/>
           <a:p>
-            <a:pPr marL="0" indent="0">
+            <a:pPr indent="0" marL="0">
               <a:buNone/>
             </a:pPr>
             <a:r>
               <a:rPr lang="en-US" sz="1100" b="1" dirty="0">
                 <a:solidFill>
-                  <a:srgbClr val="2C5F2D"/>
+                  <a:srgbClr val="3D5A5B"/>
                 </a:solidFill>
                 <a:latin typeface="Calibri" pitchFamily="34" charset="0"/>
                 <a:ea typeface="Calibri" pitchFamily="34" charset="-122"/>
@@ -4141,10 +4567,13 @@
               </a:rPr>
               <a:t>Massachusetts Model:  </a:t>
             </a:r>
+            <a:pPr indent="0" marL="0">
+              <a:buNone/>
+            </a:pPr>
             <a:r>
               <a:rPr lang="en-US" sz="1000" dirty="0">
                 <a:solidFill>
-                  <a:srgbClr val="363636"/>
+                  <a:srgbClr val="2D3436"/>
                 </a:solidFill>
                 <a:latin typeface="Calibri" pitchFamily="34" charset="0"/>
                 <a:ea typeface="Calibri" pitchFamily="34" charset="-122"/>
@@ -4173,17 +4602,10 @@
             </a:avLst>
           </a:prstGeom>
           <a:solidFill>
-            <a:srgbClr val="E8F0E8"/>
+            <a:srgbClr val="E8EEEB"/>
           </a:solidFill>
           <a:ln/>
         </p:spPr>
-        <p:txBody>
-          <a:bodyPr/>
-          <a:lstStyle/>
-          <a:p>
-            <a:endParaRPr lang="en-IN"/>
-          </a:p>
-        </p:txBody>
       </p:sp>
       <p:sp>
         <p:nvSpPr>
@@ -4206,13 +4628,13 @@
           <a:bodyPr wrap="square" rtlCol="0" anchor="ctr"/>
           <a:lstStyle/>
           <a:p>
-            <a:pPr marL="0" indent="0">
+            <a:pPr indent="0" marL="0">
               <a:buNone/>
             </a:pPr>
             <a:r>
               <a:rPr lang="en-US" sz="1100" b="1" dirty="0">
                 <a:solidFill>
-                  <a:srgbClr val="2C5F2D"/>
+                  <a:srgbClr val="3D5A5B"/>
                 </a:solidFill>
                 <a:latin typeface="Calibri" pitchFamily="34" charset="0"/>
                 <a:ea typeface="Calibri" pitchFamily="34" charset="-122"/>
@@ -4220,10 +4642,13 @@
               </a:rPr>
               <a:t>ReFED Cost-Benefit:  </a:t>
             </a:r>
+            <a:pPr indent="0" marL="0">
+              <a:buNone/>
+            </a:pPr>
             <a:r>
               <a:rPr lang="en-US" sz="1000" dirty="0">
                 <a:solidFill>
-                  <a:srgbClr val="363636"/>
+                  <a:srgbClr val="2D3436"/>
                 </a:solidFill>
                 <a:latin typeface="Calibri" pitchFamily="34" charset="0"/>
                 <a:ea typeface="Calibri" pitchFamily="34" charset="-122"/>
@@ -4252,17 +4677,10 @@
             </a:avLst>
           </a:prstGeom>
           <a:solidFill>
-            <a:srgbClr val="A7BEAE"/>
+            <a:srgbClr val="C5D5CD"/>
           </a:solidFill>
           <a:ln/>
         </p:spPr>
-        <p:txBody>
-          <a:bodyPr/>
-          <a:lstStyle/>
-          <a:p>
-            <a:endParaRPr lang="en-IN"/>
-          </a:p>
-        </p:txBody>
       </p:sp>
       <p:sp>
         <p:nvSpPr>
@@ -4285,13 +4703,13 @@
           <a:bodyPr wrap="square" rtlCol="0" anchor="ctr"/>
           <a:lstStyle/>
           <a:p>
-            <a:pPr marL="0" indent="0">
+            <a:pPr indent="0" marL="0">
               <a:buNone/>
             </a:pPr>
             <a:r>
               <a:rPr lang="en-US" sz="1100" b="1" dirty="0">
                 <a:solidFill>
-                  <a:srgbClr val="2C5F2D"/>
+                  <a:srgbClr val="3D5A5B"/>
                 </a:solidFill>
                 <a:latin typeface="Calibri" pitchFamily="34" charset="0"/>
                 <a:ea typeface="Calibri" pitchFamily="34" charset="-122"/>
@@ -4299,10 +4717,13 @@
               </a:rPr>
               <a:t>Vermont Act 148:  </a:t>
             </a:r>
+            <a:pPr indent="0" marL="0">
+              <a:buNone/>
+            </a:pPr>
             <a:r>
               <a:rPr lang="en-US" sz="1000" dirty="0">
                 <a:solidFill>
-                  <a:srgbClr val="363636"/>
+                  <a:srgbClr val="2D3436"/>
                 </a:solidFill>
                 <a:latin typeface="Calibri" pitchFamily="34" charset="0"/>
                 <a:ea typeface="Calibri" pitchFamily="34" charset="-122"/>
@@ -4331,17 +4752,10 @@
             </a:avLst>
           </a:prstGeom>
           <a:solidFill>
-            <a:srgbClr val="E8F0E8"/>
+            <a:srgbClr val="E8EEEB"/>
           </a:solidFill>
           <a:ln/>
         </p:spPr>
-        <p:txBody>
-          <a:bodyPr/>
-          <a:lstStyle/>
-          <a:p>
-            <a:endParaRPr lang="en-IN"/>
-          </a:p>
-        </p:txBody>
       </p:sp>
       <p:sp>
         <p:nvSpPr>
@@ -4364,13 +4778,13 @@
           <a:bodyPr wrap="square" rtlCol="0" anchor="ctr"/>
           <a:lstStyle/>
           <a:p>
-            <a:pPr marL="0" indent="0">
+            <a:pPr indent="0" marL="0">
               <a:buNone/>
             </a:pPr>
             <a:r>
               <a:rPr lang="en-US" sz="1100" b="1" dirty="0">
                 <a:solidFill>
-                  <a:srgbClr val="2C5F2D"/>
+                  <a:srgbClr val="3D5A5B"/>
                 </a:solidFill>
                 <a:latin typeface="Calibri" pitchFamily="34" charset="0"/>
                 <a:ea typeface="Calibri" pitchFamily="34" charset="-122"/>
@@ -4378,10 +4792,13 @@
               </a:rPr>
               <a:t>France Donation Law:  </a:t>
             </a:r>
+            <a:pPr indent="0" marL="0">
+              <a:buNone/>
+            </a:pPr>
             <a:r>
               <a:rPr lang="en-US" sz="1000" dirty="0">
                 <a:solidFill>
-                  <a:srgbClr val="363636"/>
+                  <a:srgbClr val="2D3436"/>
                 </a:solidFill>
                 <a:latin typeface="Calibri" pitchFamily="34" charset="0"/>
                 <a:ea typeface="Calibri" pitchFamily="34" charset="-122"/>
@@ -4407,9 +4824,8 @@
     <p:bg>
       <p:bgPr>
         <a:solidFill>
-          <a:srgbClr val="2C5F2D"/>
+          <a:srgbClr val="3D5A5B"/>
         </a:solidFill>
-        <a:effectLst/>
       </p:bgPr>
     </p:bg>
     <p:spTree>
@@ -4447,7 +4863,7 @@
           <a:bodyPr wrap="square" rtlCol="0" anchor="ctr"/>
           <a:lstStyle/>
           <a:p>
-            <a:pPr marL="0" indent="0" algn="ctr">
+            <a:pPr algn="ctr" indent="0" marL="0">
               <a:buNone/>
             </a:pPr>
             <a:r>
@@ -4480,15 +4896,86 @@
             <a:avLst/>
           </a:prstGeom>
           <a:solidFill>
-            <a:srgbClr val="97BC62"/>
+            <a:srgbClr val="8FB3A8"/>
           </a:solidFill>
           <a:ln/>
         </p:spPr>
-        <p:txBody>
-          <a:bodyPr/>
-          <a:lstStyle/>
-          <a:p>
-            <a:endParaRPr lang="en-IN"/>
+      </p:sp>
+      <p:sp>
+        <p:nvSpPr>
+          <p:cNvPr id="4" name="Text 2"/>
+          <p:cNvSpPr/>
+          <p:nvPr/>
+        </p:nvSpPr>
+        <p:spPr>
+          <a:xfrm>
+            <a:off x="914400" y="2011680"/>
+            <a:ext cx="7315200" cy="548640"/>
+          </a:xfrm>
+          <a:prstGeom prst="rect">
+            <a:avLst/>
+          </a:prstGeom>
+          <a:noFill/>
+          <a:ln/>
+        </p:spPr>
+        <p:txBody>
+          <a:bodyPr wrap="square" rtlCol="0" anchor="ctr"/>
+          <a:lstStyle/>
+          <a:p>
+            <a:pPr algn="ctr" indent="0" marL="0">
+              <a:buNone/>
+            </a:pPr>
+            <a:r>
+              <a:rPr lang="en-US" sz="1800" i="1" dirty="0">
+                <a:solidFill>
+                  <a:srgbClr val="8FB3A8"/>
+                </a:solidFill>
+                <a:latin typeface="Calibri" pitchFamily="34" charset="0"/>
+                <a:ea typeface="Calibri" pitchFamily="34" charset="-122"/>
+                <a:cs typeface="Calibri" pitchFamily="34" charset="-120"/>
+              </a:rPr>
+              <a:t>The evidence is causal. The framework is proven. Act now.</a:t>
+            </a:r>
+            <a:endParaRPr lang="en-US" sz="1800" dirty="0"/>
+          </a:p>
+        </p:txBody>
+      </p:sp>
+      <p:sp>
+        <p:nvSpPr>
+          <p:cNvPr id="5" name="Text 3"/>
+          <p:cNvSpPr/>
+          <p:nvPr/>
+        </p:nvSpPr>
+        <p:spPr>
+          <a:xfrm>
+            <a:off x="457200" y="2926080"/>
+            <a:ext cx="8229600" cy="365760"/>
+          </a:xfrm>
+          <a:prstGeom prst="rect">
+            <a:avLst/>
+          </a:prstGeom>
+          <a:noFill/>
+          <a:ln/>
+        </p:spPr>
+        <p:txBody>
+          <a:bodyPr wrap="square" rtlCol="0" anchor="ctr"/>
+          <a:lstStyle/>
+          <a:p>
+            <a:pPr algn="ctr" indent="0" marL="0">
+              <a:buNone/>
+            </a:pPr>
+            <a:r>
+              <a:rPr lang="en-US" sz="1300" dirty="0">
+                <a:solidFill>
+                  <a:srgbClr val="FFFFFF"/>
+                </a:solidFill>
+                <a:latin typeface="Calibri" pitchFamily="34" charset="0"/>
+                <a:ea typeface="Calibri" pitchFamily="34" charset="-122"/>
+                <a:cs typeface="Calibri" pitchFamily="34" charset="-120"/>
+              </a:rPr>
+              <a:t>1M+ tons diverted  |  4.5M MT CO2e saved  |  $6.4B value  |  1.9B meals recovered</a:t>
+            </a:r>
+            <a:endParaRPr lang="en-US" sz="1300" dirty="0"/>
           </a:p>
         </p:txBody>
       </p:sp>
@@ -4500,7 +4987,7 @@
         </p:nvSpPr>
         <p:spPr>
           <a:xfrm>
-            <a:off x="947057" y="2293675"/>
+            <a:off x="914400" y="3657600"/>
             <a:ext cx="7315200" cy="548640"/>
           </a:xfrm>
           <a:prstGeom prst="rect">
@@ -4513,7 +5000,7 @@
           <a:bodyPr wrap="square" rtlCol="0" anchor="ctr"/>
           <a:lstStyle/>
           <a:p>
-            <a:pPr marL="0" indent="0" algn="ctr">
+            <a:pPr algn="ctr" indent="0" marL="0">
               <a:buNone/>
             </a:pPr>
             <a:r>
@@ -4539,7 +5026,7 @@
         </p:nvSpPr>
         <p:spPr>
           <a:xfrm>
-            <a:off x="947057" y="2933755"/>
+            <a:off x="914400" y="4297680"/>
             <a:ext cx="7315200" cy="365760"/>
           </a:xfrm>
           <a:prstGeom prst="rect">
@@ -4552,13 +5039,13 @@
           <a:bodyPr wrap="square" rtlCol="0" anchor="ctr"/>
           <a:lstStyle/>
           <a:p>
-            <a:pPr marL="0" indent="0" algn="ctr">
+            <a:pPr algn="ctr" indent="0" marL="0">
               <a:buNone/>
             </a:pPr>
             <a:r>
               <a:rPr lang="en-US" sz="1400" dirty="0">
                 <a:solidFill>
-                  <a:srgbClr val="97BC62"/>
+                  <a:srgbClr val="8FB3A8"/>
                 </a:solidFill>
                 <a:latin typeface="Calibri" pitchFamily="34" charset="0"/>
                 <a:ea typeface="Calibri" pitchFamily="34" charset="-122"/>
@@ -4584,9 +5071,8 @@
     <p:bg>
       <p:bgPr>
         <a:solidFill>
-          <a:srgbClr val="F5F5F5"/>
+          <a:srgbClr val="F8F6F3"/>
         </a:solidFill>
-        <a:effectLst/>
       </p:bgPr>
     </p:bg>
     <p:spTree>
@@ -4611,7 +5097,7 @@
         </p:nvSpPr>
         <p:spPr>
           <a:xfrm>
-            <a:off x="457200" y="126547"/>
+            <a:off x="457200" y="182880"/>
             <a:ext cx="8229600" cy="502920"/>
           </a:xfrm>
           <a:prstGeom prst="rect">
@@ -4624,13 +5110,13 @@
           <a:bodyPr wrap="square" rtlCol="0" anchor="ctr"/>
           <a:lstStyle/>
           <a:p>
-            <a:pPr marL="0" indent="0">
+            <a:pPr indent="0" marL="0">
               <a:buNone/>
             </a:pPr>
             <a:r>
               <a:rPr lang="en-US" sz="3000" b="1" dirty="0">
                 <a:solidFill>
-                  <a:srgbClr val="2C5F2D"/>
+                  <a:srgbClr val="3D5A5B"/>
                 </a:solidFill>
                 <a:latin typeface="Georgia" pitchFamily="34" charset="0"/>
                 <a:ea typeface="Georgia" pitchFamily="34" charset="-122"/>
@@ -4663,13 +5149,13 @@
           <a:bodyPr wrap="square" rtlCol="0" anchor="ctr"/>
           <a:lstStyle/>
           <a:p>
-            <a:pPr marL="0" indent="0" algn="ctr">
+            <a:pPr algn="ctr" indent="0" marL="0">
               <a:buNone/>
             </a:pPr>
             <a:r>
               <a:rPr lang="en-US" sz="4000" b="1" dirty="0">
                 <a:solidFill>
-                  <a:srgbClr val="2C5F2D"/>
+                  <a:srgbClr val="3D5A5B"/>
                 </a:solidFill>
                 <a:latin typeface="Georgia" pitchFamily="34" charset="0"/>
                 <a:ea typeface="Georgia" pitchFamily="34" charset="-122"/>
@@ -4689,7 +5175,7 @@
         </p:nvSpPr>
         <p:spPr>
           <a:xfrm>
-            <a:off x="365760" y="1848394"/>
+            <a:off x="365760" y="1554480"/>
             <a:ext cx="1828800" cy="274320"/>
           </a:xfrm>
           <a:prstGeom prst="rect">
@@ -4702,13 +5188,13 @@
           <a:bodyPr wrap="square" rtlCol="0" anchor="ctr"/>
           <a:lstStyle/>
           <a:p>
-            <a:pPr marL="0" indent="0" algn="ctr">
+            <a:pPr algn="ctr" indent="0" marL="0">
               <a:buNone/>
             </a:pPr>
             <a:r>
               <a:rPr lang="en-US" sz="1200" b="1" dirty="0">
                 <a:solidFill>
-                  <a:srgbClr val="363636"/>
+                  <a:srgbClr val="2D3436"/>
                 </a:solidFill>
                 <a:latin typeface="Calibri" pitchFamily="34" charset="0"/>
                 <a:ea typeface="Calibri" pitchFamily="34" charset="-122"/>
@@ -4728,7 +5214,7 @@
         </p:nvSpPr>
         <p:spPr>
           <a:xfrm>
-            <a:off x="365760" y="2122714"/>
+            <a:off x="365760" y="1828800"/>
             <a:ext cx="1828800" cy="228600"/>
           </a:xfrm>
           <a:prstGeom prst="rect">
@@ -4741,7 +5227,7 @@
           <a:bodyPr wrap="square" rtlCol="0" anchor="ctr"/>
           <a:lstStyle/>
           <a:p>
-            <a:pPr marL="0" indent="0" algn="ctr">
+            <a:pPr algn="ctr" indent="0" marL="0">
               <a:buNone/>
             </a:pPr>
             <a:r>
@@ -4767,8 +5253,8 @@
         </p:nvSpPr>
         <p:spPr>
           <a:xfrm>
-            <a:off x="2468879" y="1005840"/>
-            <a:ext cx="2062299" cy="548640"/>
+            <a:off x="2468880" y="1005840"/>
+            <a:ext cx="1828800" cy="548640"/>
           </a:xfrm>
           <a:prstGeom prst="rect">
             <a:avLst/>
@@ -4780,13 +5266,13 @@
           <a:bodyPr wrap="square" rtlCol="0" anchor="ctr"/>
           <a:lstStyle/>
           <a:p>
-            <a:pPr marL="0" indent="0" algn="ctr">
+            <a:pPr algn="ctr" indent="0" marL="0">
               <a:buNone/>
             </a:pPr>
             <a:r>
               <a:rPr lang="en-US" sz="4000" b="1" dirty="0">
                 <a:solidFill>
-                  <a:srgbClr val="2C5F2D"/>
+                  <a:srgbClr val="3D5A5B"/>
                 </a:solidFill>
                 <a:latin typeface="Georgia" pitchFamily="34" charset="0"/>
                 <a:ea typeface="Georgia" pitchFamily="34" charset="-122"/>
@@ -4806,7 +5292,7 @@
         </p:nvSpPr>
         <p:spPr>
           <a:xfrm>
-            <a:off x="2521948" y="1838597"/>
+            <a:off x="2468880" y="1554480"/>
             <a:ext cx="1828800" cy="274320"/>
           </a:xfrm>
           <a:prstGeom prst="rect">
@@ -4819,13 +5305,13 @@
           <a:bodyPr wrap="square" rtlCol="0" anchor="ctr"/>
           <a:lstStyle/>
           <a:p>
-            <a:pPr marL="0" indent="0" algn="ctr">
+            <a:pPr algn="ctr" indent="0" marL="0">
               <a:buNone/>
             </a:pPr>
             <a:r>
               <a:rPr lang="en-US" sz="1200" b="1" dirty="0">
                 <a:solidFill>
-                  <a:srgbClr val="363636"/>
+                  <a:srgbClr val="2D3436"/>
                 </a:solidFill>
                 <a:latin typeface="Calibri" pitchFamily="34" charset="0"/>
                 <a:ea typeface="Calibri" pitchFamily="34" charset="-122"/>
@@ -4845,7 +5331,7 @@
         </p:nvSpPr>
         <p:spPr>
           <a:xfrm>
-            <a:off x="2521948" y="2112917"/>
+            <a:off x="2468880" y="1828800"/>
             <a:ext cx="1828800" cy="228600"/>
           </a:xfrm>
           <a:prstGeom prst="rect">
@@ -4858,7 +5344,7 @@
           <a:bodyPr wrap="square" rtlCol="0" anchor="ctr"/>
           <a:lstStyle/>
           <a:p>
-            <a:pPr marL="0" indent="0" algn="ctr">
+            <a:pPr algn="ctr" indent="0" marL="0">
               <a:buNone/>
             </a:pPr>
             <a:r>
@@ -4897,13 +5383,13 @@
           <a:bodyPr wrap="square" rtlCol="0" anchor="ctr"/>
           <a:lstStyle/>
           <a:p>
-            <a:pPr marL="0" indent="0" algn="ctr">
+            <a:pPr algn="ctr" indent="0" marL="0">
               <a:buNone/>
             </a:pPr>
             <a:r>
               <a:rPr lang="en-US" sz="4000" b="1" dirty="0">
                 <a:solidFill>
-                  <a:srgbClr val="2C5F2D"/>
+                  <a:srgbClr val="3D5A5B"/>
                 </a:solidFill>
                 <a:latin typeface="Georgia" pitchFamily="34" charset="0"/>
                 <a:ea typeface="Georgia" pitchFamily="34" charset="-122"/>
@@ -4936,13 +5422,13 @@
           <a:bodyPr wrap="square" rtlCol="0" anchor="ctr"/>
           <a:lstStyle/>
           <a:p>
-            <a:pPr marL="0" indent="0" algn="ctr">
+            <a:pPr algn="ctr" indent="0" marL="0">
               <a:buNone/>
             </a:pPr>
             <a:r>
               <a:rPr lang="en-US" sz="1200" b="1" dirty="0">
                 <a:solidFill>
-                  <a:srgbClr val="363636"/>
+                  <a:srgbClr val="2D3436"/>
                 </a:solidFill>
                 <a:latin typeface="Calibri" pitchFamily="34" charset="0"/>
                 <a:ea typeface="Calibri" pitchFamily="34" charset="-122"/>
@@ -4975,7 +5461,7 @@
           <a:bodyPr wrap="square" rtlCol="0" anchor="ctr"/>
           <a:lstStyle/>
           <a:p>
-            <a:pPr marL="0" indent="0" algn="ctr">
+            <a:pPr algn="ctr" indent="0" marL="0">
               <a:buNone/>
             </a:pPr>
             <a:r>
@@ -5001,8 +5487,8 @@
         </p:nvSpPr>
         <p:spPr>
           <a:xfrm>
-            <a:off x="6441622" y="1005840"/>
-            <a:ext cx="3041195" cy="548640"/>
+            <a:off x="6675120" y="1005840"/>
+            <a:ext cx="1828800" cy="548640"/>
           </a:xfrm>
           <a:prstGeom prst="rect">
             <a:avLst/>
@@ -5014,19 +5500,19 @@
           <a:bodyPr wrap="square" rtlCol="0" anchor="ctr"/>
           <a:lstStyle/>
           <a:p>
-            <a:pPr marL="0" indent="0" algn="ctr">
+            <a:pPr algn="ctr" indent="0" marL="0">
               <a:buNone/>
             </a:pPr>
             <a:r>
               <a:rPr lang="en-US" sz="4000" b="1" dirty="0">
                 <a:solidFill>
-                  <a:srgbClr val="2C5F2D"/>
+                  <a:srgbClr val="3D5A5B"/>
                 </a:solidFill>
                 <a:latin typeface="Georgia" pitchFamily="34" charset="0"/>
                 <a:ea typeface="Georgia" pitchFamily="34" charset="-122"/>
                 <a:cs typeface="Georgia" pitchFamily="34" charset="-120"/>
               </a:rPr>
-              <a:t>221M CO2e</a:t>
+              <a:t>221M MT CO2e</a:t>
             </a:r>
             <a:endParaRPr lang="en-US" sz="4000" dirty="0"/>
           </a:p>
@@ -5040,7 +5526,7 @@
         </p:nvSpPr>
         <p:spPr>
           <a:xfrm>
-            <a:off x="6949440" y="1874520"/>
+            <a:off x="6675120" y="1554480"/>
             <a:ext cx="1828800" cy="274320"/>
           </a:xfrm>
           <a:prstGeom prst="rect">
@@ -5053,13 +5539,13 @@
           <a:bodyPr wrap="square" rtlCol="0" anchor="ctr"/>
           <a:lstStyle/>
           <a:p>
-            <a:pPr marL="0" indent="0" algn="ctr">
+            <a:pPr algn="ctr" indent="0" marL="0">
               <a:buNone/>
             </a:pPr>
             <a:r>
               <a:rPr lang="en-US" sz="1200" b="1" dirty="0">
                 <a:solidFill>
-                  <a:srgbClr val="363636"/>
+                  <a:srgbClr val="2D3436"/>
                 </a:solidFill>
                 <a:latin typeface="Calibri" pitchFamily="34" charset="0"/>
                 <a:ea typeface="Calibri" pitchFamily="34" charset="-122"/>
@@ -5079,7 +5565,7 @@
         </p:nvSpPr>
         <p:spPr>
           <a:xfrm>
-            <a:off x="6949440" y="2148840"/>
+            <a:off x="6675120" y="1828800"/>
             <a:ext cx="1828800" cy="228600"/>
           </a:xfrm>
           <a:prstGeom prst="rect">
@@ -5092,7 +5578,7 @@
           <a:bodyPr wrap="square" rtlCol="0" anchor="ctr"/>
           <a:lstStyle/>
           <a:p>
-            <a:pPr marL="0" indent="0" algn="ctr">
+            <a:pPr algn="ctr" indent="0" marL="0">
               <a:buNone/>
             </a:pPr>
             <a:r>
@@ -5119,7 +5605,7 @@
         <p:spPr>
           <a:xfrm>
             <a:off x="1828800" y="2834640"/>
-            <a:ext cx="2216604" cy="548640"/>
+            <a:ext cx="1828800" cy="548640"/>
           </a:xfrm>
           <a:prstGeom prst="rect">
             <a:avLst/>
@@ -5131,13 +5617,13 @@
           <a:bodyPr wrap="square" rtlCol="0" anchor="ctr"/>
           <a:lstStyle/>
           <a:p>
-            <a:pPr marL="0" indent="0" algn="ctr">
+            <a:pPr algn="ctr" indent="0" marL="0">
               <a:buNone/>
             </a:pPr>
             <a:r>
               <a:rPr lang="en-US" sz="4000" b="1" dirty="0">
                 <a:solidFill>
-                  <a:srgbClr val="2C5F2D"/>
+                  <a:srgbClr val="3D5A5B"/>
                 </a:solidFill>
                 <a:latin typeface="Georgia" pitchFamily="34" charset="0"/>
                 <a:ea typeface="Georgia" pitchFamily="34" charset="-122"/>
@@ -5157,7 +5643,7 @@
         </p:nvSpPr>
         <p:spPr>
           <a:xfrm>
-            <a:off x="1934937" y="3677194"/>
+            <a:off x="1828800" y="3383280"/>
             <a:ext cx="1828800" cy="274320"/>
           </a:xfrm>
           <a:prstGeom prst="rect">
@@ -5170,13 +5656,13 @@
           <a:bodyPr wrap="square" rtlCol="0" anchor="ctr"/>
           <a:lstStyle/>
           <a:p>
-            <a:pPr marL="0" indent="0" algn="ctr">
+            <a:pPr algn="ctr" indent="0" marL="0">
               <a:buNone/>
             </a:pPr>
             <a:r>
               <a:rPr lang="en-US" sz="1200" b="1" dirty="0">
                 <a:solidFill>
-                  <a:srgbClr val="363636"/>
+                  <a:srgbClr val="2D3436"/>
                 </a:solidFill>
                 <a:latin typeface="Calibri" pitchFamily="34" charset="0"/>
                 <a:ea typeface="Calibri" pitchFamily="34" charset="-122"/>
@@ -5196,7 +5682,7 @@
         </p:nvSpPr>
         <p:spPr>
           <a:xfrm>
-            <a:off x="1934937" y="3951514"/>
+            <a:off x="1828800" y="3657600"/>
             <a:ext cx="1828800" cy="228600"/>
           </a:xfrm>
           <a:prstGeom prst="rect">
@@ -5209,7 +5695,7 @@
           <a:bodyPr wrap="square" rtlCol="0" anchor="ctr"/>
           <a:lstStyle/>
           <a:p>
-            <a:pPr marL="0" indent="0" algn="ctr">
+            <a:pPr algn="ctr" indent="0" marL="0">
               <a:buNone/>
             </a:pPr>
             <a:r>
@@ -5248,13 +5734,13 @@
           <a:bodyPr wrap="square" rtlCol="0" anchor="ctr"/>
           <a:lstStyle/>
           <a:p>
-            <a:pPr marL="0" indent="0" algn="ctr">
+            <a:pPr algn="ctr" indent="0" marL="0">
               <a:buNone/>
             </a:pPr>
             <a:r>
               <a:rPr lang="en-US" sz="4000" b="1" dirty="0">
                 <a:solidFill>
-                  <a:srgbClr val="2C5F2D"/>
+                  <a:srgbClr val="3D5A5B"/>
                 </a:solidFill>
                 <a:latin typeface="Georgia" pitchFamily="34" charset="0"/>
                 <a:ea typeface="Georgia" pitchFamily="34" charset="-122"/>
@@ -5274,7 +5760,7 @@
         </p:nvSpPr>
         <p:spPr>
           <a:xfrm>
-            <a:off x="5070021" y="3759653"/>
+            <a:off x="5029200" y="3383280"/>
             <a:ext cx="1828800" cy="274320"/>
           </a:xfrm>
           <a:prstGeom prst="rect">
@@ -5287,13 +5773,13 @@
           <a:bodyPr wrap="square" rtlCol="0" anchor="ctr"/>
           <a:lstStyle/>
           <a:p>
-            <a:pPr marL="0" indent="0" algn="ctr">
+            <a:pPr algn="ctr" indent="0" marL="0">
               <a:buNone/>
             </a:pPr>
             <a:r>
               <a:rPr lang="en-US" sz="1200" b="1" dirty="0">
                 <a:solidFill>
-                  <a:srgbClr val="363636"/>
+                  <a:srgbClr val="2D3436"/>
                 </a:solidFill>
                 <a:latin typeface="Calibri" pitchFamily="34" charset="0"/>
                 <a:ea typeface="Calibri" pitchFamily="34" charset="-122"/>
@@ -5313,7 +5799,7 @@
         </p:nvSpPr>
         <p:spPr>
           <a:xfrm>
-            <a:off x="5070021" y="4033973"/>
+            <a:off x="5029200" y="3657600"/>
             <a:ext cx="1828800" cy="228600"/>
           </a:xfrm>
           <a:prstGeom prst="rect">
@@ -5326,7 +5812,7 @@
           <a:bodyPr wrap="square" rtlCol="0" anchor="ctr"/>
           <a:lstStyle/>
           <a:p>
-            <a:pPr marL="0" indent="0" algn="ctr">
+            <a:pPr algn="ctr" indent="0" marL="0">
               <a:buNone/>
             </a:pPr>
             <a:r>
@@ -5365,7 +5851,7 @@
           <a:bodyPr wrap="square" rtlCol="0" anchor="ctr"/>
           <a:lstStyle/>
           <a:p>
-            <a:pPr marL="0" indent="0">
+            <a:pPr indent="0" marL="0">
               <a:buNone/>
             </a:pPr>
             <a:r>
@@ -5377,7 +5863,7 @@
                 <a:ea typeface="Calibri" pitchFamily="34" charset="-122"/>
                 <a:cs typeface="Calibri" pitchFamily="34" charset="-120"/>
               </a:rPr>
-              <a:t>Source: ReFED Food Waste Monitor, 2024 </a:t>
+              <a:t>Source: ReFED Food Waste Monitor, 2024 | Authors' analysis</a:t>
             </a:r>
             <a:endParaRPr lang="en-US" sz="800" dirty="0"/>
           </a:p>
@@ -5397,9 +5883,8 @@
     <p:bg>
       <p:bgPr>
         <a:solidFill>
-          <a:srgbClr val="F5F5F5"/>
+          <a:srgbClr val="F8F6F3"/>
         </a:solidFill>
-        <a:effectLst/>
       </p:bgPr>
     </p:bg>
     <p:spTree>
@@ -5437,13 +5922,13 @@
           <a:bodyPr wrap="square" rtlCol="0" anchor="ctr"/>
           <a:lstStyle/>
           <a:p>
-            <a:pPr marL="0" indent="0">
+            <a:pPr indent="0" marL="0">
               <a:buNone/>
             </a:pPr>
             <a:r>
               <a:rPr lang="en-US" sz="3000" b="1" dirty="0">
                 <a:solidFill>
-                  <a:srgbClr val="2C5F2D"/>
+                  <a:srgbClr val="3D5A5B"/>
                 </a:solidFill>
                 <a:latin typeface="Georgia" pitchFamily="34" charset="0"/>
                 <a:ea typeface="Georgia" pitchFamily="34" charset="-122"/>
@@ -5470,17 +5955,10 @@
             <a:avLst/>
           </a:prstGeom>
           <a:solidFill>
-            <a:srgbClr val="2C5F2D"/>
+            <a:srgbClr val="3D5A5B"/>
           </a:solidFill>
           <a:ln/>
         </p:spPr>
-        <p:txBody>
-          <a:bodyPr/>
-          <a:lstStyle/>
-          <a:p>
-            <a:endParaRPr lang="en-IN"/>
-          </a:p>
-        </p:txBody>
       </p:sp>
       <p:sp>
         <p:nvSpPr>
@@ -5503,7 +5981,7 @@
           <a:bodyPr wrap="square" rtlCol="0" anchor="ctr"/>
           <a:lstStyle/>
           <a:p>
-            <a:pPr marL="0" indent="0" algn="ctr">
+            <a:pPr algn="ctr" indent="0" marL="0">
               <a:buNone/>
             </a:pPr>
             <a:r>
@@ -5542,13 +6020,13 @@
           <a:bodyPr wrap="square" rtlCol="0" anchor="ctr"/>
           <a:lstStyle/>
           <a:p>
-            <a:pPr marL="0" indent="0" algn="ctr">
+            <a:pPr algn="ctr" indent="0" marL="0">
               <a:buNone/>
             </a:pPr>
             <a:r>
               <a:rPr lang="en-US" sz="1400" b="1" dirty="0">
                 <a:solidFill>
-                  <a:srgbClr val="2C5F2D"/>
+                  <a:srgbClr val="3D5A5B"/>
                 </a:solidFill>
                 <a:latin typeface="Georgia" pitchFamily="34" charset="0"/>
                 <a:ea typeface="Georgia" pitchFamily="34" charset="-122"/>
@@ -5581,7 +6059,7 @@
           <a:bodyPr wrap="square" rtlCol="0" anchor="ctr"/>
           <a:lstStyle/>
           <a:p>
-            <a:pPr marL="0" indent="0" algn="ctr">
+            <a:pPr algn="ctr" indent="0" marL="0">
               <a:lnSpc>
                 <a:spcPct val="115000"/>
               </a:lnSpc>
@@ -5590,7 +6068,7 @@
             <a:r>
               <a:rPr lang="en-US" sz="1000" dirty="0">
                 <a:solidFill>
-                  <a:srgbClr val="363636"/>
+                  <a:srgbClr val="2D3436"/>
                 </a:solidFill>
                 <a:latin typeface="Calibri" pitchFamily="34" charset="0"/>
                 <a:ea typeface="Calibri" pitchFamily="34" charset="-122"/>
@@ -5617,17 +6095,10 @@
             <a:avLst/>
           </a:prstGeom>
           <a:solidFill>
-            <a:srgbClr val="2C5F2D"/>
+            <a:srgbClr val="3D5A5B"/>
           </a:solidFill>
           <a:ln/>
         </p:spPr>
-        <p:txBody>
-          <a:bodyPr/>
-          <a:lstStyle/>
-          <a:p>
-            <a:endParaRPr lang="en-IN"/>
-          </a:p>
-        </p:txBody>
       </p:sp>
       <p:sp>
         <p:nvSpPr>
@@ -5650,7 +6121,7 @@
           <a:bodyPr wrap="square" rtlCol="0" anchor="ctr"/>
           <a:lstStyle/>
           <a:p>
-            <a:pPr marL="0" indent="0" algn="ctr">
+            <a:pPr algn="ctr" indent="0" marL="0">
               <a:buNone/>
             </a:pPr>
             <a:r>
@@ -5689,13 +6160,13 @@
           <a:bodyPr wrap="square" rtlCol="0" anchor="ctr"/>
           <a:lstStyle/>
           <a:p>
-            <a:pPr marL="0" indent="0" algn="ctr">
+            <a:pPr algn="ctr" indent="0" marL="0">
               <a:buNone/>
             </a:pPr>
             <a:r>
               <a:rPr lang="en-US" sz="1400" b="1" dirty="0">
                 <a:solidFill>
-                  <a:srgbClr val="2C5F2D"/>
+                  <a:srgbClr val="3D5A5B"/>
                 </a:solidFill>
                 <a:latin typeface="Georgia" pitchFamily="34" charset="0"/>
                 <a:ea typeface="Georgia" pitchFamily="34" charset="-122"/>
@@ -5728,7 +6199,7 @@
           <a:bodyPr wrap="square" rtlCol="0" anchor="ctr"/>
           <a:lstStyle/>
           <a:p>
-            <a:pPr marL="0" indent="0" algn="ctr">
+            <a:pPr algn="ctr" indent="0" marL="0">
               <a:lnSpc>
                 <a:spcPct val="115000"/>
               </a:lnSpc>
@@ -5737,7 +6208,7 @@
             <a:r>
               <a:rPr lang="en-US" sz="1000" dirty="0">
                 <a:solidFill>
-                  <a:srgbClr val="363636"/>
+                  <a:srgbClr val="2D3436"/>
                 </a:solidFill>
                 <a:latin typeface="Calibri" pitchFamily="34" charset="0"/>
                 <a:ea typeface="Calibri" pitchFamily="34" charset="-122"/>
@@ -5764,17 +6235,10 @@
             <a:avLst/>
           </a:prstGeom>
           <a:solidFill>
-            <a:srgbClr val="2C5F2D"/>
+            <a:srgbClr val="3D5A5B"/>
           </a:solidFill>
           <a:ln/>
         </p:spPr>
-        <p:txBody>
-          <a:bodyPr/>
-          <a:lstStyle/>
-          <a:p>
-            <a:endParaRPr lang="en-IN"/>
-          </a:p>
-        </p:txBody>
       </p:sp>
       <p:sp>
         <p:nvSpPr>
@@ -5797,7 +6261,7 @@
           <a:bodyPr wrap="square" rtlCol="0" anchor="ctr"/>
           <a:lstStyle/>
           <a:p>
-            <a:pPr marL="0" indent="0" algn="ctr">
+            <a:pPr algn="ctr" indent="0" marL="0">
               <a:buNone/>
             </a:pPr>
             <a:r>
@@ -5836,13 +6300,13 @@
           <a:bodyPr wrap="square" rtlCol="0" anchor="ctr"/>
           <a:lstStyle/>
           <a:p>
-            <a:pPr marL="0" indent="0" algn="ctr">
+            <a:pPr algn="ctr" indent="0" marL="0">
               <a:buNone/>
             </a:pPr>
             <a:r>
               <a:rPr lang="en-US" sz="1400" b="1" dirty="0">
                 <a:solidFill>
-                  <a:srgbClr val="2C5F2D"/>
+                  <a:srgbClr val="3D5A5B"/>
                 </a:solidFill>
                 <a:latin typeface="Georgia" pitchFamily="34" charset="0"/>
                 <a:ea typeface="Georgia" pitchFamily="34" charset="-122"/>
@@ -5875,7 +6339,7 @@
           <a:bodyPr wrap="square" rtlCol="0" anchor="ctr"/>
           <a:lstStyle/>
           <a:p>
-            <a:pPr marL="0" indent="0" algn="ctr">
+            <a:pPr algn="ctr" indent="0" marL="0">
               <a:lnSpc>
                 <a:spcPct val="115000"/>
               </a:lnSpc>
@@ -5884,7 +6348,7 @@
             <a:r>
               <a:rPr lang="en-US" sz="1000" dirty="0">
                 <a:solidFill>
-                  <a:srgbClr val="363636"/>
+                  <a:srgbClr val="2D3436"/>
                 </a:solidFill>
                 <a:latin typeface="Calibri" pitchFamily="34" charset="0"/>
                 <a:ea typeface="Calibri" pitchFamily="34" charset="-122"/>
@@ -5911,17 +6375,10 @@
             <a:avLst/>
           </a:prstGeom>
           <a:solidFill>
-            <a:srgbClr val="2C5F2D"/>
+            <a:srgbClr val="3D5A5B"/>
           </a:solidFill>
           <a:ln/>
         </p:spPr>
-        <p:txBody>
-          <a:bodyPr/>
-          <a:lstStyle/>
-          <a:p>
-            <a:endParaRPr lang="en-IN"/>
-          </a:p>
-        </p:txBody>
       </p:sp>
       <p:sp>
         <p:nvSpPr>
@@ -5944,7 +6401,7 @@
           <a:bodyPr wrap="square" rtlCol="0" anchor="ctr"/>
           <a:lstStyle/>
           <a:p>
-            <a:pPr marL="0" indent="0" algn="ctr">
+            <a:pPr algn="ctr" indent="0" marL="0">
               <a:buNone/>
             </a:pPr>
             <a:r>
@@ -5983,13 +6440,13 @@
           <a:bodyPr wrap="square" rtlCol="0" anchor="ctr"/>
           <a:lstStyle/>
           <a:p>
-            <a:pPr marL="0" indent="0" algn="ctr">
+            <a:pPr algn="ctr" indent="0" marL="0">
               <a:buNone/>
             </a:pPr>
             <a:r>
               <a:rPr lang="en-US" sz="1400" b="1" dirty="0">
                 <a:solidFill>
-                  <a:srgbClr val="2C5F2D"/>
+                  <a:srgbClr val="3D5A5B"/>
                 </a:solidFill>
                 <a:latin typeface="Georgia" pitchFamily="34" charset="0"/>
                 <a:ea typeface="Georgia" pitchFamily="34" charset="-122"/>
@@ -6022,7 +6479,7 @@
           <a:bodyPr wrap="square" rtlCol="0" anchor="ctr"/>
           <a:lstStyle/>
           <a:p>
-            <a:pPr marL="0" indent="0" algn="ctr">
+            <a:pPr algn="ctr" indent="0" marL="0">
               <a:lnSpc>
                 <a:spcPct val="115000"/>
               </a:lnSpc>
@@ -6031,7 +6488,7 @@
             <a:r>
               <a:rPr lang="en-US" sz="1000" dirty="0">
                 <a:solidFill>
-                  <a:srgbClr val="363636"/>
+                  <a:srgbClr val="2D3436"/>
                 </a:solidFill>
                 <a:latin typeface="Calibri" pitchFamily="34" charset="0"/>
                 <a:ea typeface="Calibri" pitchFamily="34" charset="-122"/>
@@ -6064,7 +6521,7 @@
           <a:bodyPr wrap="square" rtlCol="0" anchor="ctr"/>
           <a:lstStyle/>
           <a:p>
-            <a:pPr marL="0" indent="0" algn="ctr">
+            <a:pPr algn="ctr" indent="0" marL="0">
               <a:buNone/>
             </a:pPr>
             <a:r>
@@ -6081,7 +6538,7 @@
             <a:endParaRPr lang="en-US" sz="1100" dirty="0"/>
           </a:p>
           <a:p>
-            <a:pPr marL="0" indent="0" algn="ctr">
+            <a:pPr algn="ctr" indent="0" marL="0">
               <a:buNone/>
             </a:pPr>
             <a:r>
@@ -6113,9 +6570,8 @@
     <p:bg>
       <p:bgPr>
         <a:solidFill>
-          <a:srgbClr val="F5F5F5"/>
+          <a:srgbClr val="F8F6F3"/>
         </a:solidFill>
-        <a:effectLst/>
       </p:bgPr>
     </p:bg>
     <p:spTree>
@@ -6153,13 +6609,13 @@
           <a:bodyPr wrap="square" rtlCol="0" anchor="ctr"/>
           <a:lstStyle/>
           <a:p>
-            <a:pPr marL="0" indent="0">
+            <a:pPr indent="0" marL="0">
               <a:buNone/>
             </a:pPr>
             <a:r>
               <a:rPr lang="en-US" sz="3000" b="1" dirty="0">
                 <a:solidFill>
-                  <a:srgbClr val="2C5F2D"/>
+                  <a:srgbClr val="3D5A5B"/>
                 </a:solidFill>
                 <a:latin typeface="Georgia" pitchFamily="34" charset="0"/>
                 <a:ea typeface="Georgia" pitchFamily="34" charset="-122"/>
@@ -6192,7 +6648,7 @@
           <a:bodyPr wrap="square" rtlCol="0" anchor="t"/>
           <a:lstStyle/>
           <a:p>
-            <a:pPr marL="0" indent="0">
+            <a:pPr indent="0" marL="0">
               <a:lnSpc>
                 <a:spcPct val="120000"/>
               </a:lnSpc>
@@ -6201,7 +6657,7 @@
             <a:r>
               <a:rPr lang="en-US" sz="1300" b="1" dirty="0">
                 <a:solidFill>
-                  <a:srgbClr val="2C5F2D"/>
+                  <a:srgbClr val="3D5A5B"/>
                 </a:solidFill>
                 <a:latin typeface="Calibri" pitchFamily="34" charset="0"/>
                 <a:ea typeface="Calibri" pitchFamily="34" charset="-122"/>
@@ -6209,10 +6665,16 @@
               </a:rPr>
               <a:t>Residential dominates: </a:t>
             </a:r>
+            <a:pPr indent="0" marL="0">
+              <a:lnSpc>
+                <a:spcPct val="120000"/>
+              </a:lnSpc>
+              <a:buNone/>
+            </a:pPr>
             <a:r>
               <a:rPr lang="en-US" sz="1200" dirty="0">
                 <a:solidFill>
-                  <a:srgbClr val="363636"/>
+                  <a:srgbClr val="2D3436"/>
                 </a:solidFill>
                 <a:latin typeface="Calibri" pitchFamily="34" charset="0"/>
                 <a:ea typeface="Calibri" pitchFamily="34" charset="-122"/>
@@ -6241,17 +6703,10 @@
             </a:avLst>
           </a:prstGeom>
           <a:solidFill>
-            <a:srgbClr val="A7BEAE"/>
+            <a:srgbClr val="C5D5CD"/>
           </a:solidFill>
           <a:ln/>
         </p:spPr>
-        <p:txBody>
-          <a:bodyPr/>
-          <a:lstStyle/>
-          <a:p>
-            <a:endParaRPr lang="en-IN"/>
-          </a:p>
-        </p:txBody>
       </p:sp>
       <p:sp>
         <p:nvSpPr>
@@ -6274,13 +6729,13 @@
           <a:bodyPr wrap="square" rtlCol="0" anchor="ctr"/>
           <a:lstStyle/>
           <a:p>
-            <a:pPr marL="0" indent="0" algn="ctr">
+            <a:pPr algn="ctr" indent="0" marL="0">
               <a:buNone/>
             </a:pPr>
             <a:r>
               <a:rPr lang="en-US" sz="2800" b="1" dirty="0">
                 <a:solidFill>
-                  <a:srgbClr val="2C5F2D"/>
+                  <a:srgbClr val="3D5A5B"/>
                 </a:solidFill>
                 <a:latin typeface="Georgia" pitchFamily="34" charset="0"/>
                 <a:ea typeface="Georgia" pitchFamily="34" charset="-122"/>
@@ -6289,10 +6744,13 @@
               <a:t>48.7%
 </a:t>
             </a:r>
+            <a:pPr algn="ctr" indent="0" marL="0">
+              <a:buNone/>
+            </a:pPr>
             <a:r>
               <a:rPr lang="en-US" sz="1100" dirty="0">
                 <a:solidFill>
-                  <a:srgbClr val="363636"/>
+                  <a:srgbClr val="2D3436"/>
                 </a:solidFill>
                 <a:latin typeface="Calibri" pitchFamily="34" charset="0"/>
                 <a:ea typeface="Calibri" pitchFamily="34" charset="-122"/>
@@ -6306,14 +6764,14 @@
       </p:sp>
       <p:pic>
         <p:nvPicPr>
-          <p:cNvPr id="6" name="Image 0" descr="C:\Users\venka\OneDrive\Desktop\Class\Events\Datathon Spring 26\agent-pipeline\files\outputs\analysis\charts\sector_breakdown.png"/>
+          <p:cNvPr id="6" name="Image 0" descr="C:\Users\venka\OneDrive\Desktop\Class\Events\Datathon Spring 26\agent-pipeline\files\outputs\analysis\charts\sector_breakdown.png">    </p:cNvPr>
           <p:cNvPicPr>
             <a:picLocks noChangeAspect="1"/>
           </p:cNvPicPr>
           <p:nvPr/>
         </p:nvPicPr>
         <p:blipFill>
-          <a:blip r:embed="rId3"/>
+          <a:blip r:embed="rId1"/>
           <a:stretch>
             <a:fillRect/>
           </a:stretch>
@@ -6349,7 +6807,7 @@
           <a:bodyPr wrap="square" rtlCol="0" anchor="ctr"/>
           <a:lstStyle/>
           <a:p>
-            <a:pPr marL="0" indent="0">
+            <a:pPr indent="0" marL="0">
               <a:buNone/>
             </a:pPr>
             <a:r>
@@ -6361,7 +6819,7 @@
                 <a:ea typeface="Calibri" pitchFamily="34" charset="-122"/>
                 <a:cs typeface="Calibri" pitchFamily="34" charset="-120"/>
               </a:rPr>
-              <a:t>Source: ReFED Food Waste Monitor, 2024</a:t>
+              <a:t>Source: ReFED Food Waste Monitor, 2024 | Authors' analysis</a:t>
             </a:r>
             <a:endParaRPr lang="en-US" sz="800" dirty="0"/>
           </a:p>
@@ -6381,9 +6839,8 @@
     <p:bg>
       <p:bgPr>
         <a:solidFill>
-          <a:srgbClr val="F5F5F5"/>
+          <a:srgbClr val="F8F6F3"/>
         </a:solidFill>
-        <a:effectLst/>
       </p:bgPr>
     </p:bg>
     <p:spTree>
@@ -6421,13 +6878,13 @@
           <a:bodyPr wrap="square" rtlCol="0" anchor="ctr"/>
           <a:lstStyle/>
           <a:p>
-            <a:pPr marL="0" indent="0">
+            <a:pPr indent="0" marL="0">
               <a:buNone/>
             </a:pPr>
             <a:r>
               <a:rPr lang="en-US" sz="3000" b="1" dirty="0">
                 <a:solidFill>
-                  <a:srgbClr val="2C5F2D"/>
+                  <a:srgbClr val="3D5A5B"/>
                 </a:solidFill>
                 <a:latin typeface="Georgia" pitchFamily="34" charset="0"/>
                 <a:ea typeface="Georgia" pitchFamily="34" charset="-122"/>
@@ -6441,14 +6898,14 @@
       </p:sp>
       <p:pic>
         <p:nvPicPr>
-          <p:cNvPr id="3" name="Image 0" descr="C:\Users\venka\OneDrive\Desktop\Class\Events\Datathon Spring 26\agent-pipeline\files\outputs\analysis\charts\trend_over_time.png"/>
+          <p:cNvPr id="3" name="Image 0" descr="C:\Users\venka\OneDrive\Desktop\Class\Events\Datathon Spring 26\agent-pipeline\files\outputs\analysis\charts\trend_over_time.png">    </p:cNvPr>
           <p:cNvPicPr>
             <a:picLocks noChangeAspect="1"/>
           </p:cNvPicPr>
           <p:nvPr/>
         </p:nvPicPr>
         <p:blipFill>
-          <a:blip r:embed="rId3"/>
+          <a:blip r:embed="rId1"/>
           <a:stretch>
             <a:fillRect/>
           </a:stretch>
@@ -6484,7 +6941,7 @@
           <a:bodyPr wrap="square" rtlCol="0" anchor="ctr"/>
           <a:lstStyle/>
           <a:p>
-            <a:pPr marL="0" indent="0">
+            <a:pPr indent="0" marL="0">
               <a:buNone/>
             </a:pPr>
             <a:r>
@@ -6516,9 +6973,8 @@
     <p:bg>
       <p:bgPr>
         <a:solidFill>
-          <a:srgbClr val="F5F5F5"/>
+          <a:srgbClr val="F8F6F3"/>
         </a:solidFill>
-        <a:effectLst/>
       </p:bgPr>
     </p:bg>
     <p:spTree>
@@ -6556,13 +7012,13 @@
           <a:bodyPr wrap="square" rtlCol="0" anchor="ctr"/>
           <a:lstStyle/>
           <a:p>
-            <a:pPr marL="0" indent="0">
+            <a:pPr indent="0" marL="0">
               <a:buNone/>
             </a:pPr>
             <a:r>
               <a:rPr lang="en-US" sz="3000" b="1" dirty="0">
                 <a:solidFill>
-                  <a:srgbClr val="2C5F2D"/>
+                  <a:srgbClr val="3D5A5B"/>
                 </a:solidFill>
                 <a:latin typeface="Georgia" pitchFamily="34" charset="0"/>
                 <a:ea typeface="Georgia" pitchFamily="34" charset="-122"/>
@@ -6576,14 +7032,14 @@
       </p:sp>
       <p:pic>
         <p:nvPicPr>
-          <p:cNvPr id="3" name="Image 0" descr="C:\Users\venka\OneDrive\Desktop\Class\Events\Datathon Spring 26\agent-pipeline\files\outputs\analysis\charts\cause_analysis.png"/>
+          <p:cNvPr id="3" name="Image 0" descr="C:\Users\venka\OneDrive\Desktop\Class\Events\Datathon Spring 26\agent-pipeline\files\outputs\analysis\charts\cause_analysis.png">    </p:cNvPr>
           <p:cNvPicPr>
             <a:picLocks noChangeAspect="1"/>
           </p:cNvPicPr>
           <p:nvPr/>
         </p:nvPicPr>
         <p:blipFill>
-          <a:blip r:embed="rId3"/>
+          <a:blip r:embed="rId1"/>
           <a:stretch>
             <a:fillRect/>
           </a:stretch>
@@ -6614,29 +7070,11 @@
               <a:gd name="adj" fmla="val 4000"/>
             </a:avLst>
           </a:prstGeom>
-          <a:ln/>
-        </p:spPr>
-        <p:style>
-          <a:lnRef idx="2">
-            <a:schemeClr val="accent6"/>
-          </a:lnRef>
-          <a:fillRef idx="1">
-            <a:schemeClr val="lt1"/>
-          </a:fillRef>
-          <a:effectRef idx="0">
-            <a:schemeClr val="accent6"/>
-          </a:effectRef>
-          <a:fontRef idx="minor">
-            <a:schemeClr val="dk1"/>
-          </a:fontRef>
-        </p:style>
-        <p:txBody>
-          <a:bodyPr/>
-          <a:lstStyle/>
-          <a:p>
-            <a:endParaRPr lang="en-IN"/>
-          </a:p>
-        </p:txBody>
+          <a:solidFill>
+            <a:srgbClr val="C5D5CD"/>
+          </a:solidFill>
+          <a:ln/>
+        </p:spPr>
       </p:sp>
       <p:sp>
         <p:nvSpPr>
@@ -6659,13 +7097,13 @@
           <a:bodyPr wrap="square" rtlCol="0" anchor="ctr"/>
           <a:lstStyle/>
           <a:p>
-            <a:pPr marL="0" indent="0" algn="ctr">
+            <a:pPr algn="ctr" indent="0" marL="0">
               <a:buNone/>
             </a:pPr>
             <a:r>
               <a:rPr lang="en-US" sz="1300" b="1" dirty="0">
                 <a:solidFill>
-                  <a:srgbClr val="2C5F2D"/>
+                  <a:srgbClr val="3D5A5B"/>
                 </a:solidFill>
                 <a:latin typeface="Georgia" pitchFamily="34" charset="0"/>
                 <a:ea typeface="Georgia" pitchFamily="34" charset="-122"/>
@@ -6674,10 +7112,13 @@
               <a:t>#1 Cause
 </a:t>
             </a:r>
+            <a:pPr algn="ctr" indent="0" marL="0">
+              <a:buNone/>
+            </a:pPr>
             <a:r>
               <a:rPr lang="en-US" sz="1400" b="1" dirty="0">
                 <a:solidFill>
-                  <a:srgbClr val="363636"/>
+                  <a:srgbClr val="2D3436"/>
                 </a:solidFill>
                 <a:latin typeface="Calibri" pitchFamily="34" charset="0"/>
                 <a:ea typeface="Calibri" pitchFamily="34" charset="-122"/>
@@ -6687,10 +7128,13 @@
 Production Line Waste
 </a:t>
             </a:r>
+            <a:pPr algn="ctr" indent="0" marL="0">
+              <a:buNone/>
+            </a:pPr>
             <a:r>
               <a:rPr lang="en-US" sz="2200" b="1" dirty="0">
                 <a:solidFill>
-                  <a:srgbClr val="F96167"/>
+                  <a:srgbClr val="C4836D"/>
                 </a:solidFill>
                 <a:latin typeface="Georgia" pitchFamily="34" charset="0"/>
                 <a:ea typeface="Georgia" pitchFamily="34" charset="-122"/>
@@ -6699,6 +7143,9 @@
               <a:t>11.9M tons
 </a:t>
             </a:r>
+            <a:pPr algn="ctr" indent="0" marL="0">
+              <a:buNone/>
+            </a:pPr>
             <a:r>
               <a:rPr lang="en-US" sz="1000" dirty="0">
                 <a:solidFill>
@@ -6735,7 +7182,7 @@
           <a:bodyPr wrap="square" rtlCol="0" anchor="ctr"/>
           <a:lstStyle/>
           <a:p>
-            <a:pPr marL="0" indent="0">
+            <a:pPr indent="0" marL="0">
               <a:buNone/>
             </a:pPr>
             <a:r>
@@ -6747,7 +7194,7 @@
                 <a:ea typeface="Calibri" pitchFamily="34" charset="-122"/>
                 <a:cs typeface="Calibri" pitchFamily="34" charset="-120"/>
               </a:rPr>
-              <a:t>Source: ReFED Food Waste Monitor, 2024 </a:t>
+              <a:t>Source: ReFED Food Waste Monitor, 2024 | Authors' analysis</a:t>
             </a:r>
             <a:endParaRPr lang="en-US" sz="800" dirty="0"/>
           </a:p>
@@ -6767,9 +7214,8 @@
     <p:bg>
       <p:bgPr>
         <a:solidFill>
-          <a:srgbClr val="F5F5F5"/>
+          <a:srgbClr val="F8F6F3"/>
         </a:solidFill>
-        <a:effectLst/>
       </p:bgPr>
     </p:bg>
     <p:spTree>
@@ -6807,13 +7253,13 @@
           <a:bodyPr wrap="square" rtlCol="0" anchor="ctr"/>
           <a:lstStyle/>
           <a:p>
-            <a:pPr marL="0" indent="0">
+            <a:pPr indent="0" marL="0">
               <a:buNone/>
             </a:pPr>
             <a:r>
               <a:rPr lang="en-US" sz="3000" b="1" dirty="0">
                 <a:solidFill>
-                  <a:srgbClr val="2C5F2D"/>
+                  <a:srgbClr val="3D5A5B"/>
                 </a:solidFill>
                 <a:latin typeface="Georgia" pitchFamily="34" charset="0"/>
                 <a:ea typeface="Georgia" pitchFamily="34" charset="-122"/>
@@ -6827,14 +7273,14 @@
       </p:sp>
       <p:pic>
         <p:nvPicPr>
-          <p:cNvPr id="3" name="Image 0" descr="C:\Users\venka\OneDrive\Desktop\Class\Events\Datathon Spring 26\agent-pipeline\files\outputs\analysis\charts\donation_gap.png"/>
+          <p:cNvPr id="3" name="Image 0" descr="C:\Users\venka\OneDrive\Desktop\Class\Events\Datathon Spring 26\agent-pipeline\files\outputs\analysis\charts\donation_gap.png">    </p:cNvPr>
           <p:cNvPicPr>
             <a:picLocks noChangeAspect="1"/>
           </p:cNvPicPr>
           <p:nvPr/>
         </p:nvPicPr>
         <p:blipFill>
-          <a:blip r:embed="rId3"/>
+          <a:blip r:embed="rId1"/>
           <a:stretch>
             <a:fillRect/>
           </a:stretch>
@@ -6865,29 +7311,16 @@
               <a:gd name="adj" fmla="val 4545"/>
             </a:avLst>
           </a:prstGeom>
-          <a:ln/>
-        </p:spPr>
-        <p:style>
-          <a:lnRef idx="2">
-            <a:schemeClr val="accent2"/>
-          </a:lnRef>
-          <a:fillRef idx="1">
-            <a:schemeClr val="lt1"/>
-          </a:fillRef>
-          <a:effectRef idx="0">
-            <a:schemeClr val="accent2"/>
-          </a:effectRef>
-          <a:fontRef idx="minor">
-            <a:schemeClr val="dk1"/>
-          </a:fontRef>
-        </p:style>
-        <p:txBody>
-          <a:bodyPr/>
-          <a:lstStyle/>
-          <a:p>
-            <a:endParaRPr lang="en-IN"/>
-          </a:p>
-        </p:txBody>
+          <a:solidFill>
+            <a:srgbClr val="F5EDEA"/>
+          </a:solidFill>
+          <a:ln w="25400">
+            <a:solidFill>
+              <a:srgbClr val="C4836D"/>
+            </a:solidFill>
+            <a:prstDash val="solid"/>
+          </a:ln>
+        </p:spPr>
       </p:sp>
       <p:sp>
         <p:nvSpPr>
@@ -6910,13 +7343,13 @@
           <a:bodyPr wrap="square" rtlCol="0" anchor="ctr"/>
           <a:lstStyle/>
           <a:p>
-            <a:pPr marL="0" indent="0" algn="ctr">
+            <a:pPr algn="ctr" indent="0" marL="0">
               <a:buNone/>
             </a:pPr>
             <a:r>
               <a:rPr lang="en-US" sz="1400" b="1" dirty="0">
                 <a:solidFill>
-                  <a:srgbClr val="F96167"/>
+                  <a:srgbClr val="C4836D"/>
                 </a:solidFill>
                 <a:latin typeface="Georgia" pitchFamily="34" charset="0"/>
                 <a:ea typeface="Georgia" pitchFamily="34" charset="-122"/>
@@ -6925,10 +7358,13 @@
               <a:t>Residential Sector
 </a:t>
             </a:r>
+            <a:pPr algn="ctr" indent="0" marL="0">
+              <a:buNone/>
+            </a:pPr>
             <a:r>
               <a:rPr lang="en-US" sz="1200" dirty="0">
                 <a:solidFill>
-                  <a:srgbClr val="363636"/>
+                  <a:srgbClr val="2D3436"/>
                 </a:solidFill>
                 <a:latin typeface="Calibri" pitchFamily="34" charset="0"/>
                 <a:ea typeface="Calibri" pitchFamily="34" charset="-122"/>
@@ -6938,10 +7374,13 @@
 $141B value
 </a:t>
             </a:r>
+            <a:pPr algn="ctr" indent="0" marL="0">
+              <a:buNone/>
+            </a:pPr>
             <a:r>
               <a:rPr lang="en-US" sz="1800" b="1" dirty="0">
                 <a:solidFill>
-                  <a:srgbClr val="F96167"/>
+                  <a:srgbClr val="C4836D"/>
                 </a:solidFill>
                 <a:latin typeface="Georgia" pitchFamily="34" charset="0"/>
                 <a:ea typeface="Georgia" pitchFamily="34" charset="-122"/>
@@ -6974,7 +7413,7 @@
           <a:bodyPr wrap="square" rtlCol="0" anchor="ctr"/>
           <a:lstStyle/>
           <a:p>
-            <a:pPr marL="0" indent="0">
+            <a:pPr indent="0" marL="0">
               <a:buNone/>
             </a:pPr>
             <a:r>
@@ -6986,7 +7425,7 @@
                 <a:ea typeface="Calibri" pitchFamily="34" charset="-122"/>
                 <a:cs typeface="Calibri" pitchFamily="34" charset="-120"/>
               </a:rPr>
-              <a:t>Source: ReFED Food Waste Monitor, 2024</a:t>
+              <a:t>Source: ReFED Food Waste Monitor, 2024 | Authors' analysis</a:t>
             </a:r>
             <a:endParaRPr lang="en-US" sz="800" dirty="0"/>
           </a:p>
@@ -7006,9 +7445,8 @@
     <p:bg>
       <p:bgPr>
         <a:solidFill>
-          <a:srgbClr val="2C5F2D"/>
+          <a:srgbClr val="3D5A5B"/>
         </a:solidFill>
-        <a:effectLst/>
       </p:bgPr>
     </p:bg>
     <p:spTree>
@@ -7046,7 +7484,7 @@
           <a:bodyPr wrap="square" rtlCol="0" anchor="ctr"/>
           <a:lstStyle/>
           <a:p>
-            <a:pPr marL="0" indent="0" algn="ctr">
+            <a:pPr algn="ctr" indent="0" marL="0">
               <a:buNone/>
             </a:pPr>
             <a:r>
@@ -7085,13 +7523,13 @@
           <a:bodyPr wrap="square" rtlCol="0" anchor="ctr"/>
           <a:lstStyle/>
           <a:p>
-            <a:pPr marL="0" indent="0" algn="ctr">
+            <a:pPr algn="ctr" indent="0" marL="0">
               <a:buNone/>
             </a:pPr>
             <a:r>
               <a:rPr lang="en-US" sz="1800" i="1" dirty="0">
                 <a:solidFill>
-                  <a:srgbClr val="97BC62"/>
+                  <a:srgbClr val="8FB3A8"/>
                 </a:solidFill>
                 <a:latin typeface="Calibri" pitchFamily="34" charset="0"/>
                 <a:ea typeface="Calibri" pitchFamily="34" charset="-122"/>
@@ -7118,17 +7556,10 @@
             <a:avLst/>
           </a:prstGeom>
           <a:solidFill>
-            <a:srgbClr val="97BC62"/>
+            <a:srgbClr val="8FB3A8"/>
           </a:solidFill>
           <a:ln/>
         </p:spPr>
-        <p:txBody>
-          <a:bodyPr/>
-          <a:lstStyle/>
-          <a:p>
-            <a:endParaRPr lang="en-IN"/>
-          </a:p>
-        </p:txBody>
       </p:sp>
     </p:spTree>
   </p:cSld>
@@ -7144,9 +7575,8 @@
     <p:bg>
       <p:bgPr>
         <a:solidFill>
-          <a:srgbClr val="F5F5F5"/>
+          <a:srgbClr val="F8F6F3"/>
         </a:solidFill>
-        <a:effectLst/>
       </p:bgPr>
     </p:bg>
     <p:spTree>
@@ -7184,13 +7614,13 @@
           <a:bodyPr wrap="square" rtlCol="0" anchor="ctr"/>
           <a:lstStyle/>
           <a:p>
-            <a:pPr marL="0" indent="0">
+            <a:pPr indent="0" marL="0">
               <a:buNone/>
             </a:pPr>
             <a:r>
               <a:rPr lang="en-US" sz="3000" b="1" dirty="0">
                 <a:solidFill>
-                  <a:srgbClr val="2C5F2D"/>
+                  <a:srgbClr val="3D5A5B"/>
                 </a:solidFill>
                 <a:latin typeface="Georgia" pitchFamily="34" charset="0"/>
                 <a:ea typeface="Georgia" pitchFamily="34" charset="-122"/>
@@ -7204,14 +7634,14 @@
       </p:sp>
       <p:pic>
         <p:nvPicPr>
-          <p:cNvPr id="3" name="Image 0" descr="C:\Users\venka\OneDrive\Desktop\Class\Events\Datathon Spring 26\agent-pipeline\files\outputs\ml\charts\shap_bar.png"/>
+          <p:cNvPr id="3" name="Image 0" descr="C:\Users\venka\OneDrive\Desktop\Class\Events\Datathon Spring 26\agent-pipeline\files\outputs\ml\charts\shap_bar.png">    </p:cNvPr>
           <p:cNvPicPr>
             <a:picLocks noChangeAspect="1"/>
           </p:cNvPicPr>
           <p:nvPr/>
         </p:nvPicPr>
         <p:blipFill>
-          <a:blip r:embed="rId3"/>
+          <a:blip r:embed="rId1"/>
           <a:stretch>
             <a:fillRect/>
           </a:stretch>
@@ -7242,29 +7672,11 @@
               <a:gd name="adj" fmla="val 3571"/>
             </a:avLst>
           </a:prstGeom>
-          <a:ln/>
-        </p:spPr>
-        <p:style>
-          <a:lnRef idx="2">
-            <a:schemeClr val="accent6"/>
-          </a:lnRef>
-          <a:fillRef idx="1">
-            <a:schemeClr val="lt1"/>
-          </a:fillRef>
-          <a:effectRef idx="0">
-            <a:schemeClr val="accent6"/>
-          </a:effectRef>
-          <a:fontRef idx="minor">
-            <a:schemeClr val="dk1"/>
-          </a:fontRef>
-        </p:style>
-        <p:txBody>
-          <a:bodyPr/>
-          <a:lstStyle/>
-          <a:p>
-            <a:endParaRPr lang="en-IN"/>
-          </a:p>
-        </p:txBody>
+          <a:solidFill>
+            <a:srgbClr val="C5D5CD"/>
+          </a:solidFill>
+          <a:ln/>
+        </p:spPr>
       </p:sp>
       <p:sp>
         <p:nvSpPr>
@@ -7287,13 +7699,13 @@
           <a:bodyPr wrap="square" rtlCol="0" anchor="ctr"/>
           <a:lstStyle/>
           <a:p>
-            <a:pPr marL="0" indent="0">
+            <a:pPr indent="0" marL="0">
               <a:buNone/>
             </a:pPr>
             <a:r>
               <a:rPr lang="en-US" sz="1400" b="1" dirty="0">
                 <a:solidFill>
-                  <a:srgbClr val="2C5F2D"/>
+                  <a:srgbClr val="3D5A5B"/>
                 </a:solidFill>
                 <a:latin typeface="Georgia" pitchFamily="34" charset="0"/>
                 <a:ea typeface="Georgia" pitchFamily="34" charset="-122"/>
@@ -7302,10 +7714,13 @@
               <a:t>Key Insight
 </a:t>
             </a:r>
+            <a:pPr indent="0" marL="0">
+              <a:buNone/>
+            </a:pPr>
             <a:r>
               <a:rPr lang="en-US" sz="1100" dirty="0">
                 <a:solidFill>
-                  <a:srgbClr val="363636"/>
+                  <a:srgbClr val="2D3436"/>
                 </a:solidFill>
                 <a:latin typeface="Calibri" pitchFamily="34" charset="0"/>
                 <a:ea typeface="Calibri" pitchFamily="34" charset="-122"/>
@@ -7313,10 +7728,13 @@
               </a:rPr>
               <a:t>State infrastructure is </a:t>
             </a:r>
+            <a:pPr indent="0" marL="0">
+              <a:buNone/>
+            </a:pPr>
             <a:r>
               <a:rPr lang="en-US" sz="1100" b="1" dirty="0">
                 <a:solidFill>
-                  <a:srgbClr val="F96167"/>
+                  <a:srgbClr val="C4836D"/>
                 </a:solidFill>
                 <a:latin typeface="Calibri" pitchFamily="34" charset="0"/>
                 <a:ea typeface="Calibri" pitchFamily="34" charset="-122"/>
@@ -7324,10 +7742,13 @@
               </a:rPr>
               <a:t>6x more important </a:t>
             </a:r>
+            <a:pPr indent="0" marL="0">
+              <a:buNone/>
+            </a:pPr>
             <a:r>
               <a:rPr lang="en-US" sz="1100" dirty="0">
                 <a:solidFill>
-                  <a:srgbClr val="363636"/>
+                  <a:srgbClr val="2D3436"/>
                 </a:solidFill>
                 <a:latin typeface="Calibri" pitchFamily="34" charset="0"/>
                 <a:ea typeface="Calibri" pitchFamily="34" charset="-122"/>
@@ -7336,6 +7757,9 @@
               <a:t>than ban status for predicting diversion success
 </a:t>
             </a:r>
+            <a:pPr indent="0" marL="0">
+              <a:buNone/>
+            </a:pPr>
             <a:r>
               <a:rPr lang="en-US" sz="1100" dirty="0">
                 <a:solidFill>
@@ -7350,7 +7774,7 @@
             <a:endParaRPr lang="en-US" sz="1400" dirty="0"/>
           </a:p>
           <a:p>
-            <a:pPr marL="0" indent="0">
+            <a:pPr indent="0" marL="0">
               <a:buNone/>
             </a:pPr>
             <a:r>
@@ -7389,7 +7813,7 @@
           <a:bodyPr wrap="square" rtlCol="0" anchor="ctr"/>
           <a:lstStyle/>
           <a:p>
-            <a:pPr marL="0" indent="0">
+            <a:pPr indent="0" marL="0">
               <a:buNone/>
             </a:pPr>
             <a:r>
@@ -7401,7 +7825,7 @@
                 <a:ea typeface="Calibri" pitchFamily="34" charset="-122"/>
                 <a:cs typeface="Calibri" pitchFamily="34" charset="-120"/>
               </a:rPr>
-              <a:t>Model CV R² = 0.9448 (landfill) | 0.9714 (diversion)</a:t>
+              <a:t>Model CV R² = 0.9448 (landfill) | 0.9714 (diversion) | N = 216,930</a:t>
             </a:r>
             <a:endParaRPr lang="en-US" sz="800" dirty="0"/>
           </a:p>
@@ -7708,319 +8132,4 @@
     </a:ext>
   </a:extLst>
 </a:theme>
-</file>
-
-<file path=ppt/theme/theme2.xml><?xml version="1.0" encoding="utf-8"?>
-<a:theme xmlns:a="http://schemas.openxmlformats.org/drawingml/2006/main" name="Office Theme">
-  <a:themeElements>
-    <a:clrScheme name="Office">
-      <a:dk1>
-        <a:sysClr val="windowText" lastClr="000000"/>
-      </a:dk1>
-      <a:lt1>
-        <a:sysClr val="window" lastClr="FFFFFF"/>
-      </a:lt1>
-      <a:dk2>
-        <a:srgbClr val="0E2841"/>
-      </a:dk2>
-      <a:lt2>
-        <a:srgbClr val="E8E8E8"/>
-      </a:lt2>
-      <a:accent1>
-        <a:srgbClr val="156082"/>
-      </a:accent1>
-      <a:accent2>
-        <a:srgbClr val="E97132"/>
-      </a:accent2>
-      <a:accent3>
-        <a:srgbClr val="196B24"/>
-      </a:accent3>
-      <a:accent4>
-        <a:srgbClr val="0F9ED5"/>
-      </a:accent4>
-      <a:accent5>
-        <a:srgbClr val="A02B93"/>
-      </a:accent5>
-      <a:accent6>
-        <a:srgbClr val="4EA72E"/>
-      </a:accent6>
-      <a:hlink>
-        <a:srgbClr val="467886"/>
-      </a:hlink>
-      <a:folHlink>
-        <a:srgbClr val="96607D"/>
-      </a:folHlink>
-    </a:clrScheme>
-    <a:fontScheme name="Office">
-      <a:majorFont>
-        <a:latin typeface="Aptos Display" panose="02110004020202020204"/>
-        <a:ea typeface=""/>
-        <a:cs typeface=""/>
-        <a:font script="Jpan" typeface="游ゴシック Light"/>
-        <a:font script="Hang" typeface="맑은 고딕"/>
-        <a:font script="Hans" typeface="等线 Light"/>
-        <a:font script="Hant" typeface="新細明體"/>
-        <a:font script="Arab" typeface="Times New Roman"/>
-        <a:font script="Hebr" typeface="Times New Roman"/>
-        <a:font script="Thai" typeface="Angsana New"/>
-        <a:font script="Ethi" typeface="Nyala"/>
-        <a:font script="Beng" typeface="Vrinda"/>
-        <a:font script="Gujr" typeface="Shruti"/>
-        <a:font script="Khmr" typeface="MoolBoran"/>
-        <a:font script="Knda" typeface="Tunga"/>
-        <a:font script="Guru" typeface="Raavi"/>
-        <a:font script="Cans" typeface="Euphemia"/>
-        <a:font script="Cher" typeface="Plantagenet Cherokee"/>
-        <a:font script="Yiii" typeface="Microsoft Yi Baiti"/>
-        <a:font script="Tibt" typeface="Microsoft Himalaya"/>
-        <a:font script="Thaa" typeface="MV Boli"/>
-        <a:font script="Deva" typeface="Mangal"/>
-        <a:font script="Telu" typeface="Gautami"/>
-        <a:font script="Taml" typeface="Latha"/>
-        <a:font script="Syrc" typeface="Estrangelo Edessa"/>
-        <a:font script="Orya" typeface="Kalinga"/>
-        <a:font script="Mlym" typeface="Kartika"/>
-        <a:font script="Laoo" typeface="DokChampa"/>
-        <a:font script="Sinh" typeface="Iskoola Pota"/>
-        <a:font script="Mong" typeface="Mongolian Baiti"/>
-        <a:font script="Viet" typeface="Times New Roman"/>
-        <a:font script="Uigh" typeface="Microsoft Uighur"/>
-        <a:font script="Geor" typeface="Sylfaen"/>
-        <a:font script="Armn" typeface="Arial"/>
-        <a:font script="Bugi" typeface="Leelawadee UI"/>
-        <a:font script="Bopo" typeface="Microsoft JhengHei"/>
-        <a:font script="Java" typeface="Javanese Text"/>
-        <a:font script="Lisu" typeface="Segoe UI"/>
-        <a:font script="Mymr" typeface="Myanmar Text"/>
-        <a:font script="Nkoo" typeface="Ebrima"/>
-        <a:font script="Olck" typeface="Nirmala UI"/>
-        <a:font script="Osma" typeface="Ebrima"/>
-        <a:font script="Phag" typeface="Phagspa"/>
-        <a:font script="Syrn" typeface="Estrangelo Edessa"/>
-        <a:font script="Syrj" typeface="Estrangelo Edessa"/>
-        <a:font script="Syre" typeface="Estrangelo Edessa"/>
-        <a:font script="Sora" typeface="Nirmala UI"/>
-        <a:font script="Tale" typeface="Microsoft Tai Le"/>
-        <a:font script="Talu" typeface="Microsoft New Tai Lue"/>
-        <a:font script="Tfng" typeface="Ebrima"/>
-      </a:majorFont>
-      <a:minorFont>
-        <a:latin typeface="Aptos" panose="02110004020202020204"/>
-        <a:ea typeface=""/>
-        <a:cs typeface=""/>
-        <a:font script="Jpan" typeface="游ゴシック"/>
-        <a:font script="Hang" typeface="맑은 고딕"/>
-        <a:font script="Hans" typeface="等线"/>
-        <a:font script="Hant" typeface="新細明體"/>
-        <a:font script="Arab" typeface="Arial"/>
-        <a:font script="Hebr" typeface="Arial"/>
-        <a:font script="Thai" typeface="Cordia New"/>
-        <a:font script="Ethi" typeface="Nyala"/>
-        <a:font script="Beng" typeface="Vrinda"/>
-        <a:font script="Gujr" typeface="Shruti"/>
-        <a:font script="Khmr" typeface="DaunPenh"/>
-        <a:font script="Knda" typeface="Tunga"/>
-        <a:font script="Guru" typeface="Raavi"/>
-        <a:font script="Cans" typeface="Euphemia"/>
-        <a:font script="Cher" typeface="Plantagenet Cherokee"/>
-        <a:font script="Yiii" typeface="Microsoft Yi Baiti"/>
-        <a:font script="Tibt" typeface="Microsoft Himalaya"/>
-        <a:font script="Thaa" typeface="MV Boli"/>
-        <a:font script="Deva" typeface="Mangal"/>
-        <a:font script="Telu" typeface="Gautami"/>
-        <a:font script="Taml" typeface="Latha"/>
-        <a:font script="Syrc" typeface="Estrangelo Edessa"/>
-        <a:font script="Orya" typeface="Kalinga"/>
-        <a:font script="Mlym" typeface="Kartika"/>
-        <a:font script="Laoo" typeface="DokChampa"/>
-        <a:font script="Sinh" typeface="Iskoola Pota"/>
-        <a:font script="Mong" typeface="Mongolian Baiti"/>
-        <a:font script="Viet" typeface="Arial"/>
-        <a:font script="Uigh" typeface="Microsoft Uighur"/>
-        <a:font script="Geor" typeface="Sylfaen"/>
-        <a:font script="Armn" typeface="Arial"/>
-        <a:font script="Bugi" typeface="Leelawadee UI"/>
-        <a:font script="Bopo" typeface="Microsoft JhengHei"/>
-        <a:font script="Java" typeface="Javanese Text"/>
-        <a:font script="Lisu" typeface="Segoe UI"/>
-        <a:font script="Mymr" typeface="Myanmar Text"/>
-        <a:font script="Nkoo" typeface="Ebrima"/>
-        <a:font script="Olck" typeface="Nirmala UI"/>
-        <a:font script="Osma" typeface="Ebrima"/>
-        <a:font script="Phag" typeface="Phagspa"/>
-        <a:font script="Syrn" typeface="Estrangelo Edessa"/>
-        <a:font script="Syrj" typeface="Estrangelo Edessa"/>
-        <a:font script="Syre" typeface="Estrangelo Edessa"/>
-        <a:font script="Sora" typeface="Nirmala UI"/>
-        <a:font script="Tale" typeface="Microsoft Tai Le"/>
-        <a:font script="Talu" typeface="Microsoft New Tai Lue"/>
-        <a:font script="Tfng" typeface="Ebrima"/>
-      </a:minorFont>
-    </a:fontScheme>
-    <a:fmtScheme name="Office">
-      <a:fillStyleLst>
-        <a:solidFill>
-          <a:schemeClr val="phClr"/>
-        </a:solidFill>
-        <a:gradFill rotWithShape="1">
-          <a:gsLst>
-            <a:gs pos="0">
-              <a:schemeClr val="phClr">
-                <a:lumMod val="110000"/>
-                <a:satMod val="105000"/>
-                <a:tint val="67000"/>
-              </a:schemeClr>
-            </a:gs>
-            <a:gs pos="50000">
-              <a:schemeClr val="phClr">
-                <a:lumMod val="105000"/>
-                <a:satMod val="103000"/>
-                <a:tint val="73000"/>
-              </a:schemeClr>
-            </a:gs>
-            <a:gs pos="100000">
-              <a:schemeClr val="phClr">
-                <a:lumMod val="105000"/>
-                <a:satMod val="109000"/>
-                <a:tint val="81000"/>
-              </a:schemeClr>
-            </a:gs>
-          </a:gsLst>
-          <a:lin ang="5400000" scaled="0"/>
-        </a:gradFill>
-        <a:gradFill rotWithShape="1">
-          <a:gsLst>
-            <a:gs pos="0">
-              <a:schemeClr val="phClr">
-                <a:satMod val="103000"/>
-                <a:lumMod val="102000"/>
-                <a:tint val="94000"/>
-              </a:schemeClr>
-            </a:gs>
-            <a:gs pos="50000">
-              <a:schemeClr val="phClr">
-                <a:satMod val="110000"/>
-                <a:lumMod val="100000"/>
-                <a:shade val="100000"/>
-              </a:schemeClr>
-            </a:gs>
-            <a:gs pos="100000">
-              <a:schemeClr val="phClr">
-                <a:lumMod val="99000"/>
-                <a:satMod val="120000"/>
-                <a:shade val="78000"/>
-              </a:schemeClr>
-            </a:gs>
-          </a:gsLst>
-          <a:lin ang="5400000" scaled="0"/>
-        </a:gradFill>
-      </a:fillStyleLst>
-      <a:lnStyleLst>
-        <a:ln w="12700" cap="flat" cmpd="sng" algn="ctr">
-          <a:solidFill>
-            <a:schemeClr val="phClr"/>
-          </a:solidFill>
-          <a:prstDash val="solid"/>
-          <a:miter lim="800000"/>
-        </a:ln>
-        <a:ln w="19050" cap="flat" cmpd="sng" algn="ctr">
-          <a:solidFill>
-            <a:schemeClr val="phClr"/>
-          </a:solidFill>
-          <a:prstDash val="solid"/>
-          <a:miter lim="800000"/>
-        </a:ln>
-        <a:ln w="25400" cap="flat" cmpd="sng" algn="ctr">
-          <a:solidFill>
-            <a:schemeClr val="phClr"/>
-          </a:solidFill>
-          <a:prstDash val="solid"/>
-          <a:miter lim="800000"/>
-        </a:ln>
-      </a:lnStyleLst>
-      <a:effectStyleLst>
-        <a:effectStyle>
-          <a:effectLst/>
-        </a:effectStyle>
-        <a:effectStyle>
-          <a:effectLst/>
-        </a:effectStyle>
-        <a:effectStyle>
-          <a:effectLst>
-            <a:outerShdw blurRad="57150" dist="19050" dir="5400000" algn="ctr" rotWithShape="0">
-              <a:srgbClr val="000000">
-                <a:alpha val="63000"/>
-              </a:srgbClr>
-            </a:outerShdw>
-          </a:effectLst>
-        </a:effectStyle>
-      </a:effectStyleLst>
-      <a:bgFillStyleLst>
-        <a:solidFill>
-          <a:schemeClr val="phClr"/>
-        </a:solidFill>
-        <a:solidFill>
-          <a:schemeClr val="phClr">
-            <a:tint val="95000"/>
-            <a:satMod val="170000"/>
-          </a:schemeClr>
-        </a:solidFill>
-        <a:gradFill rotWithShape="1">
-          <a:gsLst>
-            <a:gs pos="0">
-              <a:schemeClr val="phClr">
-                <a:tint val="93000"/>
-                <a:satMod val="150000"/>
-                <a:shade val="98000"/>
-                <a:lumMod val="102000"/>
-              </a:schemeClr>
-            </a:gs>
-            <a:gs pos="50000">
-              <a:schemeClr val="phClr">
-                <a:tint val="98000"/>
-                <a:satMod val="130000"/>
-                <a:shade val="90000"/>
-                <a:lumMod val="103000"/>
-              </a:schemeClr>
-            </a:gs>
-            <a:gs pos="100000">
-              <a:schemeClr val="phClr">
-                <a:shade val="63000"/>
-                <a:satMod val="120000"/>
-              </a:schemeClr>
-            </a:gs>
-          </a:gsLst>
-          <a:lin ang="5400000" scaled="0"/>
-        </a:gradFill>
-      </a:bgFillStyleLst>
-    </a:fmtScheme>
-  </a:themeElements>
-  <a:objectDefaults>
-    <a:lnDef>
-      <a:spPr/>
-      <a:bodyPr/>
-      <a:lstStyle/>
-      <a:style>
-        <a:lnRef idx="2">
-          <a:schemeClr val="accent1"/>
-        </a:lnRef>
-        <a:fillRef idx="0">
-          <a:schemeClr val="accent1"/>
-        </a:fillRef>
-        <a:effectRef idx="1">
-          <a:schemeClr val="accent1"/>
-        </a:effectRef>
-        <a:fontRef idx="minor">
-          <a:schemeClr val="tx1"/>
-        </a:fontRef>
-      </a:style>
-    </a:lnDef>
-  </a:objectDefaults>
-  <a:extraClrSchemeLst/>
-  <a:extLst>
-    <a:ext uri="{05A4C25C-085E-4340-85A3-A5531E510DB2}">
-      <thm15:themeFamily xmlns:thm15="http://schemas.microsoft.com/office/thememl/2012/main" name="Office Theme" id="{2E142A2C-CD16-42D6-873A-C26D2A0506FA}" vid="{1BDDFF52-6CD6-40A5-AB3C-68EB2F1E4D0A}"/>
-    </a:ext>
-  </a:extLst>
-</a:theme>
 </file>
</xml_diff>